<commit_message>
Document Rule 201 plain-English closeout
</commit_message>
<xml_diff>
--- a/edge_discovery_lab/presentations/edl_ms_01_attention_falsification.pptx
+++ b/edge_discovery_lab/presentations/edl_ms_01_attention_falsification.pptx
@@ -2,19 +2,20 @@
 <file path=ppt/presentation.xml><?xml version="1.0" encoding="utf-8"?>
 <p:presentation xmlns:p="http://schemas.openxmlformats.org/presentationml/2006/main">
   <p:sldMasterIdLst>
-    <p:sldMasterId xmlns:r="http://schemas.openxmlformats.org/officeDocument/2006/relationships" id="2147483648" r:id="R0d077e77c9df48bb"/>
+    <p:sldMasterId xmlns:r="http://schemas.openxmlformats.org/officeDocument/2006/relationships" id="2147483648" r:id="Rada6dca54e6e49da"/>
   </p:sldMasterIdLst>
   <p:notesMasterIdLst>
-    <p:notesMasterId xmlns:r="http://schemas.openxmlformats.org/officeDocument/2006/relationships" r:id="R7e8c4b97c72e4252"/>
+    <p:notesMasterId xmlns:r="http://schemas.openxmlformats.org/officeDocument/2006/relationships" r:id="R5aa9da50ec0e4780"/>
   </p:notesMasterIdLst>
   <p:sldIdLst>
-    <p:sldId xmlns:r="http://schemas.openxmlformats.org/officeDocument/2006/relationships" id="256" r:id="Rfc0c49be2a494f2e"/>
-    <p:sldId xmlns:r="http://schemas.openxmlformats.org/officeDocument/2006/relationships" id="257" r:id="R66d61c48c927401c"/>
-    <p:sldId xmlns:r="http://schemas.openxmlformats.org/officeDocument/2006/relationships" id="258" r:id="Rba2b9b55f9a641ef"/>
-    <p:sldId xmlns:r="http://schemas.openxmlformats.org/officeDocument/2006/relationships" id="259" r:id="R2fa1999e90d0417f"/>
-    <p:sldId xmlns:r="http://schemas.openxmlformats.org/officeDocument/2006/relationships" id="260" r:id="Rddd75878f9b745ee"/>
-    <p:sldId xmlns:r="http://schemas.openxmlformats.org/officeDocument/2006/relationships" id="261" r:id="R5a0ea3611eb340d9"/>
-    <p:sldId xmlns:r="http://schemas.openxmlformats.org/officeDocument/2006/relationships" id="262" r:id="Rcb12f8a9519147e0"/>
+    <p:sldId xmlns:r="http://schemas.openxmlformats.org/officeDocument/2006/relationships" id="256" r:id="R44ea0de3fcfb4f71"/>
+    <p:sldId xmlns:r="http://schemas.openxmlformats.org/officeDocument/2006/relationships" id="257" r:id="R35ec6ec8065f42c2"/>
+    <p:sldId xmlns:r="http://schemas.openxmlformats.org/officeDocument/2006/relationships" id="258" r:id="R7a83df34a0b74065"/>
+    <p:sldId xmlns:r="http://schemas.openxmlformats.org/officeDocument/2006/relationships" id="259" r:id="Rf25ad023e03842d8"/>
+    <p:sldId xmlns:r="http://schemas.openxmlformats.org/officeDocument/2006/relationships" id="260" r:id="R0dfc5d9cc5c24462"/>
+    <p:sldId xmlns:r="http://schemas.openxmlformats.org/officeDocument/2006/relationships" id="261" r:id="R1c012f660c504f15"/>
+    <p:sldId xmlns:r="http://schemas.openxmlformats.org/officeDocument/2006/relationships" id="262" r:id="Rf49d04a5627a4d22"/>
+    <p:sldId xmlns:r="http://schemas.openxmlformats.org/officeDocument/2006/relationships" id="263" r:id="Ra4cd7b473b164d5f"/>
   </p:sldIdLst>
   <p:sldSz cx="12192000" cy="6858000"/>
   <p:notesSz cx="6858000" cy="9144000"/>
@@ -1083,6 +1084,106 @@
 </p:notes>
 </file>
 
+<file path=ppt/notesSlides/notesSlide8.xml><?xml version="1.0" encoding="utf-8"?>
+<p:notes xmlns:p="http://schemas.openxmlformats.org/presentationml/2006/main">
+  <p:cSld>
+    <p:spTree>
+      <p:nvGrpSpPr>
+        <p:cNvPr id="1" name=""/>
+        <p:cNvGrpSpPr/>
+        <p:nvPr/>
+      </p:nvGrpSpPr>
+      <p:grpSpPr>
+        <a:xfrm xmlns:a="http://schemas.openxmlformats.org/drawingml/2006/main"/>
+      </p:grpSpPr>
+      <p:sp>
+        <p:nvSpPr>
+          <p:cNvPr id="2" name="Slide Image Placeholder 1"/>
+          <p:cNvSpPr>
+            <a:spLocks xmlns:a="http://schemas.openxmlformats.org/drawingml/2006/main" noGrp="1"/>
+          </p:cNvSpPr>
+          <p:nvPr>
+            <p:ph type="sldImg" idx="0"/>
+          </p:nvPr>
+        </p:nvSpPr>
+        <p:spPr/>
+      </p:sp>
+      <p:sp>
+        <p:nvSpPr>
+          <p:cNvPr id="3" name="Notes Placeholder 2"/>
+          <p:cNvSpPr>
+            <a:spLocks xmlns:a="http://schemas.openxmlformats.org/drawingml/2006/main" noGrp="1"/>
+          </p:cNvSpPr>
+          <p:nvPr>
+            <p:ph type="body" idx="1"/>
+          </p:nvPr>
+        </p:nvSpPr>
+        <p:spPr/>
+        <p:txBody>
+          <a:bodyPr xmlns:a="http://schemas.openxmlformats.org/drawingml/2006/main"/>
+          <a:lstStyle xmlns:a="http://schemas.openxmlformats.org/drawingml/2006/main"/>
+          <a:p xmlns:a="http://schemas.openxmlformats.org/drawingml/2006/main">
+            <a:r>
+              <a:t>This slide summarizes the complete Rule 201 investigation in plain English. The original ten-stock pilot showed a temporary median rebound near session five. The balanced 88-stock core did not reproduce it. The apparent attention-stock explanation then reversed in the frozen matched follow-up, while the match-balance gate also failed. The result is a better-defined research question, not a tradable rule.</a:t>
+            </a:r>
+          </a:p>
+          <a:p xmlns:a="http://schemas.openxmlformats.org/drawingml/2006/main">
+            <a:r>
+              <a:t/>
+            </a:r>
+          </a:p>
+          <a:p xmlns:a="http://schemas.openxmlformats.org/drawingml/2006/main">
+            <a:r>
+              <a:t>[Sources]</a:t>
+            </a:r>
+          </a:p>
+          <a:p xmlns:a="http://schemas.openxmlformats.org/drawingml/2006/main">
+            <a:r>
+              <a:t>- Local forward-path report: runs/research_workbench/edge_discovery_lab/edl_ms_01_rule201_forward_path_20260830/report.md</a:t>
+            </a:r>
+          </a:p>
+          <a:p xmlns:a="http://schemas.openxmlformats.org/drawingml/2006/main">
+            <a:r>
+              <a:t>- Local wide-atlas report: runs/research_workbench/edge_discovery_lab/edl_ms_01_rule201_wide_atlas_20260830/report.md</a:t>
+            </a:r>
+          </a:p>
+          <a:p xmlns:a="http://schemas.openxmlformats.org/drawingml/2006/main">
+            <a:r>
+              <a:t>- Local attention falsification report: runs/research_workbench/edge_discovery_lab/edl_ms_01_attention_falsification_20260831/report.md</a:t>
+            </a:r>
+          </a:p>
+          <a:p xmlns:a="http://schemas.openxmlformats.org/drawingml/2006/main">
+            <a:r>
+              <a:t>[/Sources]</a:t>
+            </a:r>
+          </a:p>
+        </p:txBody>
+      </p:sp>
+      <p:sp>
+        <p:nvSpPr>
+          <p:cNvPr id="4" name="Slide Number Placeholder 3"/>
+          <p:cNvSpPr>
+            <a:spLocks xmlns:a="http://schemas.openxmlformats.org/drawingml/2006/main" noGrp="1"/>
+          </p:cNvSpPr>
+          <p:nvPr>
+            <p:ph type="sldNum" idx="5"/>
+          </p:nvPr>
+        </p:nvSpPr>
+        <p:spPr/>
+        <p:txBody>
+          <a:bodyPr xmlns:a="http://schemas.openxmlformats.org/drawingml/2006/main"/>
+          <a:lstStyle xmlns:a="http://schemas.openxmlformats.org/drawingml/2006/main"/>
+          <a:p xmlns:a="http://schemas.openxmlformats.org/drawingml/2006/main"/>
+        </p:txBody>
+      </p:sp>
+    </p:spTree>
+  </p:cSld>
+  <p:clrMapOvr>
+    <a:masterClrMapping xmlns:a="http://schemas.openxmlformats.org/drawingml/2006/main"/>
+  </p:clrMapOvr>
+</p:notes>
+</file>
+
 <file path=ppt/slideLayouts/slideLayout1.xml><?xml version="1.0" encoding="utf-8"?>
 <p:sldLayout xmlns:p="http://schemas.openxmlformats.org/presentationml/2006/main" type="title">
   <p:cSld name="Title Slide">
@@ -1121,7 +1222,7 @@
   </p:cSld>
   <p:clrMap bg1="lt1" tx1="dk1" bg2="lt2" tx2="dk2" accent1="accent1" accent2="accent2" accent3="accent3" accent4="accent4" accent5="accent5" accent6="accent6" hlink="hlink" folHlink="folHlink"/>
   <p:sldLayoutIdLst>
-    <p:sldLayoutId xmlns:r="http://schemas.openxmlformats.org/officeDocument/2006/relationships" id="2147483649" r:id="R4576585f27e74cae"/>
+    <p:sldLayoutId xmlns:r="http://schemas.openxmlformats.org/officeDocument/2006/relationships" id="2147483649" r:id="Rd57c2fd065db45ce"/>
   </p:sldLayoutIdLst>
   <p:txStyles>
     <p:titleStyle>
@@ -1733,6 +1834,7 @@
           <a:lstStyle xmlns:a="http://schemas.openxmlformats.org/drawingml/2006/main"/>
           <a:p xmlns:a="http://schemas.openxmlformats.org/drawingml/2006/main">
             <a:pPr algn="l">
+              <a:buNone/>
               <a:defRPr sz="1200" b="1">
                 <a:solidFill>
                   <a:srgbClr val="667386"/>
@@ -1783,6 +1885,7 @@
           <a:lstStyle xmlns:a="http://schemas.openxmlformats.org/drawingml/2006/main"/>
           <a:p xmlns:a="http://schemas.openxmlformats.org/drawingml/2006/main">
             <a:pPr algn="l">
+              <a:buNone/>
               <a:defRPr sz="4350" b="1">
                 <a:solidFill>
                   <a:srgbClr val="000000"/>
@@ -1833,6 +1936,7 @@
           <a:lstStyle xmlns:a="http://schemas.openxmlformats.org/drawingml/2006/main"/>
           <a:p xmlns:a="http://schemas.openxmlformats.org/drawingml/2006/main">
             <a:pPr algn="l">
+              <a:buNone/>
               <a:defRPr sz="2625" b="1">
                 <a:solidFill>
                   <a:srgbClr val="B44738"/>
@@ -1883,6 +1987,7 @@
           <a:lstStyle xmlns:a="http://schemas.openxmlformats.org/drawingml/2006/main"/>
           <a:p xmlns:a="http://schemas.openxmlformats.org/drawingml/2006/main">
             <a:pPr algn="l">
+              <a:buNone/>
               <a:defRPr sz="1800" b="0">
                 <a:solidFill>
                   <a:srgbClr val="24364B"/>
@@ -1966,6 +2071,7 @@
           <a:lstStyle xmlns:a="http://schemas.openxmlformats.org/drawingml/2006/main"/>
           <a:p xmlns:a="http://schemas.openxmlformats.org/drawingml/2006/main">
             <a:pPr algn="ctr">
+              <a:buNone/>
               <a:defRPr sz="4800" b="1">
                 <a:solidFill>
                   <a:srgbClr val="FFFFFF"/>
@@ -2016,6 +2122,7 @@
           <a:lstStyle xmlns:a="http://schemas.openxmlformats.org/drawingml/2006/main"/>
           <a:p xmlns:a="http://schemas.openxmlformats.org/drawingml/2006/main">
             <a:pPr algn="ctr">
+              <a:buNone/>
               <a:defRPr sz="1650" b="0">
                 <a:solidFill>
                   <a:srgbClr val="D0EDFA"/>
@@ -2099,6 +2206,7 @@
           <a:lstStyle xmlns:a="http://schemas.openxmlformats.org/drawingml/2006/main"/>
           <a:p xmlns:a="http://schemas.openxmlformats.org/drawingml/2006/main">
             <a:pPr algn="l">
+              <a:buNone/>
               <a:defRPr sz="1275" b="1">
                 <a:solidFill>
                   <a:srgbClr val="B44738"/>
@@ -2149,6 +2257,7 @@
           <a:lstStyle xmlns:a="http://schemas.openxmlformats.org/drawingml/2006/main"/>
           <a:p xmlns:a="http://schemas.openxmlformats.org/drawingml/2006/main">
             <a:pPr algn="r">
+              <a:buNone/>
               <a:defRPr sz="1275" b="1">
                 <a:solidFill>
                   <a:srgbClr val="667386"/>
@@ -2228,6 +2337,7 @@
           <a:lstStyle xmlns:a="http://schemas.openxmlformats.org/drawingml/2006/main"/>
           <a:p xmlns:a="http://schemas.openxmlformats.org/drawingml/2006/main">
             <a:pPr algn="l">
+              <a:buNone/>
               <a:defRPr sz="1050" b="1">
                 <a:solidFill>
                   <a:srgbClr val="667386"/>
@@ -2278,6 +2388,7 @@
           <a:lstStyle xmlns:a="http://schemas.openxmlformats.org/drawingml/2006/main"/>
           <a:p xmlns:a="http://schemas.openxmlformats.org/drawingml/2006/main">
             <a:pPr algn="l">
+              <a:buNone/>
               <a:defRPr sz="2700" b="1">
                 <a:solidFill>
                   <a:srgbClr val="000000"/>
@@ -2328,6 +2439,7 @@
           <a:lstStyle xmlns:a="http://schemas.openxmlformats.org/drawingml/2006/main"/>
           <a:p xmlns:a="http://schemas.openxmlformats.org/drawingml/2006/main">
             <a:pPr algn="l">
+              <a:buNone/>
               <a:defRPr sz="1350" b="0">
                 <a:solidFill>
                   <a:srgbClr val="667386"/>
@@ -2411,6 +2523,7 @@
           <a:lstStyle xmlns:a="http://schemas.openxmlformats.org/drawingml/2006/main"/>
           <a:p xmlns:a="http://schemas.openxmlformats.org/drawingml/2006/main">
             <a:pPr algn="l">
+              <a:buNone/>
               <a:defRPr sz="900" b="0">
                 <a:solidFill>
                   <a:srgbClr val="667386"/>
@@ -2461,6 +2574,7 @@
           <a:lstStyle xmlns:a="http://schemas.openxmlformats.org/drawingml/2006/main"/>
           <a:p xmlns:a="http://schemas.openxmlformats.org/drawingml/2006/main">
             <a:pPr algn="r">
+              <a:buNone/>
               <a:defRPr sz="900" b="0">
                 <a:solidFill>
                   <a:srgbClr val="667386"/>
@@ -2577,6 +2691,7 @@
           <a:lstStyle xmlns:a="http://schemas.openxmlformats.org/drawingml/2006/main"/>
           <a:p xmlns:a="http://schemas.openxmlformats.org/drawingml/2006/main">
             <a:pPr algn="l">
+              <a:buNone/>
               <a:defRPr sz="2625" b="1">
                 <a:solidFill>
                   <a:srgbClr val="3D8DFF"/>
@@ -2627,6 +2742,7 @@
           <a:lstStyle xmlns:a="http://schemas.openxmlformats.org/drawingml/2006/main"/>
           <a:p xmlns:a="http://schemas.openxmlformats.org/drawingml/2006/main">
             <a:pPr algn="l">
+              <a:buNone/>
               <a:defRPr sz="1275" b="1">
                 <a:solidFill>
                   <a:srgbClr val="24364B"/>
@@ -2677,6 +2793,7 @@
           <a:lstStyle xmlns:a="http://schemas.openxmlformats.org/drawingml/2006/main"/>
           <a:p xmlns:a="http://schemas.openxmlformats.org/drawingml/2006/main">
             <a:pPr algn="l">
+              <a:buNone/>
               <a:defRPr sz="975" b="0">
                 <a:solidFill>
                   <a:srgbClr val="667386"/>
@@ -2793,6 +2910,7 @@
           <a:lstStyle xmlns:a="http://schemas.openxmlformats.org/drawingml/2006/main"/>
           <a:p xmlns:a="http://schemas.openxmlformats.org/drawingml/2006/main">
             <a:pPr algn="l">
+              <a:buNone/>
               <a:defRPr sz="2625" b="1">
                 <a:solidFill>
                   <a:srgbClr val="6957D5"/>
@@ -2843,6 +2961,7 @@
           <a:lstStyle xmlns:a="http://schemas.openxmlformats.org/drawingml/2006/main"/>
           <a:p xmlns:a="http://schemas.openxmlformats.org/drawingml/2006/main">
             <a:pPr algn="l">
+              <a:buNone/>
               <a:defRPr sz="1275" b="1">
                 <a:solidFill>
                   <a:srgbClr val="24364B"/>
@@ -2893,6 +3012,7 @@
           <a:lstStyle xmlns:a="http://schemas.openxmlformats.org/drawingml/2006/main"/>
           <a:p xmlns:a="http://schemas.openxmlformats.org/drawingml/2006/main">
             <a:pPr algn="l">
+              <a:buNone/>
               <a:defRPr sz="975" b="0">
                 <a:solidFill>
                   <a:srgbClr val="667386"/>
@@ -3009,6 +3129,7 @@
           <a:lstStyle xmlns:a="http://schemas.openxmlformats.org/drawingml/2006/main"/>
           <a:p xmlns:a="http://schemas.openxmlformats.org/drawingml/2006/main">
             <a:pPr algn="l">
+              <a:buNone/>
               <a:defRPr sz="2625" b="1">
                 <a:solidFill>
                   <a:srgbClr val="14866D"/>
@@ -3059,6 +3180,7 @@
           <a:lstStyle xmlns:a="http://schemas.openxmlformats.org/drawingml/2006/main"/>
           <a:p xmlns:a="http://schemas.openxmlformats.org/drawingml/2006/main">
             <a:pPr algn="l">
+              <a:buNone/>
               <a:defRPr sz="1275" b="1">
                 <a:solidFill>
                   <a:srgbClr val="24364B"/>
@@ -3109,6 +3231,7 @@
           <a:lstStyle xmlns:a="http://schemas.openxmlformats.org/drawingml/2006/main"/>
           <a:p xmlns:a="http://schemas.openxmlformats.org/drawingml/2006/main">
             <a:pPr algn="l">
+              <a:buNone/>
               <a:defRPr sz="975" b="0">
                 <a:solidFill>
                   <a:srgbClr val="667386"/>
@@ -3225,6 +3348,7 @@
           <a:lstStyle xmlns:a="http://schemas.openxmlformats.org/drawingml/2006/main"/>
           <a:p xmlns:a="http://schemas.openxmlformats.org/drawingml/2006/main">
             <a:pPr algn="l">
+              <a:buNone/>
               <a:defRPr sz="2625" b="1">
                 <a:solidFill>
                   <a:srgbClr val="A86B00"/>
@@ -3275,6 +3399,7 @@
           <a:lstStyle xmlns:a="http://schemas.openxmlformats.org/drawingml/2006/main"/>
           <a:p xmlns:a="http://schemas.openxmlformats.org/drawingml/2006/main">
             <a:pPr algn="l">
+              <a:buNone/>
               <a:defRPr sz="1275" b="1">
                 <a:solidFill>
                   <a:srgbClr val="24364B"/>
@@ -3325,6 +3450,7 @@
           <a:lstStyle xmlns:a="http://schemas.openxmlformats.org/drawingml/2006/main"/>
           <a:p xmlns:a="http://schemas.openxmlformats.org/drawingml/2006/main">
             <a:pPr algn="l">
+              <a:buNone/>
               <a:defRPr sz="975" b="0">
                 <a:solidFill>
                   <a:srgbClr val="667386"/>
@@ -3408,6 +3534,7 @@
           <a:lstStyle xmlns:a="http://schemas.openxmlformats.org/drawingml/2006/main"/>
           <a:p xmlns:a="http://schemas.openxmlformats.org/drawingml/2006/main">
             <a:pPr algn="l">
+              <a:buNone/>
               <a:defRPr sz="1200" b="1">
                 <a:solidFill>
                   <a:srgbClr val="3D8DFF"/>
@@ -3491,6 +3618,7 @@
           <a:lstStyle xmlns:a="http://schemas.openxmlformats.org/drawingml/2006/main"/>
           <a:p xmlns:a="http://schemas.openxmlformats.org/drawingml/2006/main">
             <a:pPr algn="l">
+              <a:buNone/>
               <a:defRPr sz="1500" b="0">
                 <a:solidFill>
                   <a:srgbClr val="24364B"/>
@@ -3574,6 +3702,7 @@
           <a:lstStyle xmlns:a="http://schemas.openxmlformats.org/drawingml/2006/main"/>
           <a:p xmlns:a="http://schemas.openxmlformats.org/drawingml/2006/main">
             <a:pPr algn="l">
+              <a:buNone/>
               <a:defRPr sz="1500" b="0">
                 <a:solidFill>
                   <a:srgbClr val="24364B"/>
@@ -3657,6 +3786,7 @@
           <a:lstStyle xmlns:a="http://schemas.openxmlformats.org/drawingml/2006/main"/>
           <a:p xmlns:a="http://schemas.openxmlformats.org/drawingml/2006/main">
             <a:pPr algn="l">
+              <a:buNone/>
               <a:defRPr sz="1500" b="0">
                 <a:solidFill>
                   <a:srgbClr val="24364B"/>
@@ -3740,6 +3870,7 @@
           <a:lstStyle xmlns:a="http://schemas.openxmlformats.org/drawingml/2006/main"/>
           <a:p xmlns:a="http://schemas.openxmlformats.org/drawingml/2006/main">
             <a:pPr algn="l">
+              <a:buNone/>
               <a:defRPr sz="1500" b="0">
                 <a:solidFill>
                   <a:srgbClr val="24364B"/>
@@ -3823,6 +3954,7 @@
           <a:lstStyle xmlns:a="http://schemas.openxmlformats.org/drawingml/2006/main"/>
           <a:p xmlns:a="http://schemas.openxmlformats.org/drawingml/2006/main">
             <a:pPr algn="l">
+              <a:buNone/>
               <a:defRPr sz="1200" b="1">
                 <a:solidFill>
                   <a:srgbClr val="24364B"/>
@@ -3906,6 +4038,7 @@
           <a:lstStyle xmlns:a="http://schemas.openxmlformats.org/drawingml/2006/main"/>
           <a:p xmlns:a="http://schemas.openxmlformats.org/drawingml/2006/main">
             <a:pPr algn="l">
+              <a:buNone/>
               <a:defRPr sz="1500" b="0">
                 <a:solidFill>
                   <a:srgbClr val="24364B"/>
@@ -3989,6 +4122,7 @@
           <a:lstStyle xmlns:a="http://schemas.openxmlformats.org/drawingml/2006/main"/>
           <a:p xmlns:a="http://schemas.openxmlformats.org/drawingml/2006/main">
             <a:pPr algn="l">
+              <a:buNone/>
               <a:defRPr sz="1500" b="0">
                 <a:solidFill>
                   <a:srgbClr val="24364B"/>
@@ -4072,6 +4206,7 @@
           <a:lstStyle xmlns:a="http://schemas.openxmlformats.org/drawingml/2006/main"/>
           <a:p xmlns:a="http://schemas.openxmlformats.org/drawingml/2006/main">
             <a:pPr algn="l">
+              <a:buNone/>
               <a:defRPr sz="1500" b="0">
                 <a:solidFill>
                   <a:srgbClr val="24364B"/>
@@ -4151,6 +4286,7 @@
           <a:lstStyle xmlns:a="http://schemas.openxmlformats.org/drawingml/2006/main"/>
           <a:p xmlns:a="http://schemas.openxmlformats.org/drawingml/2006/main">
             <a:pPr algn="l">
+              <a:buNone/>
               <a:defRPr sz="1050" b="1">
                 <a:solidFill>
                   <a:srgbClr val="667386"/>
@@ -4201,6 +4337,7 @@
           <a:lstStyle xmlns:a="http://schemas.openxmlformats.org/drawingml/2006/main"/>
           <a:p xmlns:a="http://schemas.openxmlformats.org/drawingml/2006/main">
             <a:pPr algn="l">
+              <a:buNone/>
               <a:defRPr sz="2700" b="1">
                 <a:solidFill>
                   <a:srgbClr val="000000"/>
@@ -4251,6 +4388,7 @@
           <a:lstStyle xmlns:a="http://schemas.openxmlformats.org/drawingml/2006/main"/>
           <a:p xmlns:a="http://schemas.openxmlformats.org/drawingml/2006/main">
             <a:pPr algn="l">
+              <a:buNone/>
               <a:defRPr sz="1350" b="0">
                 <a:solidFill>
                   <a:srgbClr val="667386"/>
@@ -4334,6 +4472,7 @@
           <a:lstStyle xmlns:a="http://schemas.openxmlformats.org/drawingml/2006/main"/>
           <a:p xmlns:a="http://schemas.openxmlformats.org/drawingml/2006/main">
             <a:pPr algn="l">
+              <a:buNone/>
               <a:defRPr sz="900" b="0">
                 <a:solidFill>
                   <a:srgbClr val="667386"/>
@@ -4384,6 +4523,7 @@
           <a:lstStyle xmlns:a="http://schemas.openxmlformats.org/drawingml/2006/main"/>
           <a:p xmlns:a="http://schemas.openxmlformats.org/drawingml/2006/main">
             <a:pPr algn="r">
+              <a:buNone/>
               <a:defRPr sz="900" b="0">
                 <a:solidFill>
                   <a:srgbClr val="667386"/>
@@ -4403,14 +4543,14 @@
       </p:sp>
       <p:pic>
         <p:nvPicPr>
-          <p:cNvPr id="21" name=""/>
+          <p:cNvPr id="23" name=""/>
           <p:cNvPicPr>
             <a:picLocks xmlns:a="http://schemas.openxmlformats.org/drawingml/2006/main" noChangeAspect="1"/>
           </p:cNvPicPr>
           <p:nvPr/>
         </p:nvPicPr>
         <p:blipFill>
-          <a:blip xmlns:r="http://schemas.openxmlformats.org/officeDocument/2006/relationships" xmlns:a="http://schemas.openxmlformats.org/drawingml/2006/main" r:embed="Ra90cead8cade4de3"/>
+          <a:blip xmlns:r="http://schemas.openxmlformats.org/officeDocument/2006/relationships" xmlns:a="http://schemas.openxmlformats.org/drawingml/2006/main" r:embed="Ra40817c7989047ca"/>
           <a:stretch xmlns:a="http://schemas.openxmlformats.org/drawingml/2006/main"/>
         </p:blipFill>
         <p:spPr>
@@ -4489,6 +4629,7 @@
           <a:lstStyle xmlns:a="http://schemas.openxmlformats.org/drawingml/2006/main"/>
           <a:p xmlns:a="http://schemas.openxmlformats.org/drawingml/2006/main">
             <a:pPr algn="ctr">
+              <a:buNone/>
               <a:defRPr sz="2775" b="1">
                 <a:solidFill>
                   <a:srgbClr val="B44738"/>
@@ -4539,6 +4680,7 @@
           <a:lstStyle xmlns:a="http://schemas.openxmlformats.org/drawingml/2006/main"/>
           <a:p xmlns:a="http://schemas.openxmlformats.org/drawingml/2006/main">
             <a:pPr algn="ctr">
+              <a:buNone/>
               <a:defRPr sz="1275" b="1">
                 <a:solidFill>
                   <a:srgbClr val="24364B"/>
@@ -4556,6 +4698,7 @@
           </a:p>
           <a:p xmlns:a="http://schemas.openxmlformats.org/drawingml/2006/main">
             <a:pPr algn="ctr">
+              <a:buNone/>
               <a:defRPr sz="1275" b="1">
                 <a:solidFill>
                   <a:srgbClr val="24364B"/>
@@ -4639,6 +4782,7 @@
           <a:lstStyle xmlns:a="http://schemas.openxmlformats.org/drawingml/2006/main"/>
           <a:p xmlns:a="http://schemas.openxmlformats.org/drawingml/2006/main">
             <a:pPr algn="ctr">
+              <a:buNone/>
               <a:defRPr sz="2775" b="1">
                 <a:solidFill>
                   <a:srgbClr val="B44738"/>
@@ -4689,6 +4833,7 @@
           <a:lstStyle xmlns:a="http://schemas.openxmlformats.org/drawingml/2006/main"/>
           <a:p xmlns:a="http://schemas.openxmlformats.org/drawingml/2006/main">
             <a:pPr algn="ctr">
+              <a:buNone/>
               <a:defRPr sz="1275" b="1">
                 <a:solidFill>
                   <a:srgbClr val="24364B"/>
@@ -4706,6 +4851,7 @@
           </a:p>
           <a:p xmlns:a="http://schemas.openxmlformats.org/drawingml/2006/main">
             <a:pPr algn="ctr">
+              <a:buNone/>
               <a:defRPr sz="1275" b="1">
                 <a:solidFill>
                   <a:srgbClr val="24364B"/>
@@ -4756,6 +4902,7 @@
           <a:lstStyle xmlns:a="http://schemas.openxmlformats.org/drawingml/2006/main"/>
           <a:p xmlns:a="http://schemas.openxmlformats.org/drawingml/2006/main">
             <a:pPr algn="l">
+              <a:buNone/>
               <a:defRPr sz="1200" b="1">
                 <a:solidFill>
                   <a:srgbClr val="24364B"/>
@@ -4835,6 +4982,7 @@
           <a:lstStyle xmlns:a="http://schemas.openxmlformats.org/drawingml/2006/main"/>
           <a:p xmlns:a="http://schemas.openxmlformats.org/drawingml/2006/main">
             <a:pPr algn="l">
+              <a:buNone/>
               <a:defRPr sz="1050" b="1">
                 <a:solidFill>
                   <a:srgbClr val="667386"/>
@@ -4885,6 +5033,7 @@
           <a:lstStyle xmlns:a="http://schemas.openxmlformats.org/drawingml/2006/main"/>
           <a:p xmlns:a="http://schemas.openxmlformats.org/drawingml/2006/main">
             <a:pPr algn="l">
+              <a:buNone/>
               <a:defRPr sz="2700" b="1">
                 <a:solidFill>
                   <a:srgbClr val="000000"/>
@@ -4935,6 +5084,7 @@
           <a:lstStyle xmlns:a="http://schemas.openxmlformats.org/drawingml/2006/main"/>
           <a:p xmlns:a="http://schemas.openxmlformats.org/drawingml/2006/main">
             <a:pPr algn="l">
+              <a:buNone/>
               <a:defRPr sz="1350" b="0">
                 <a:solidFill>
                   <a:srgbClr val="667386"/>
@@ -5018,6 +5168,7 @@
           <a:lstStyle xmlns:a="http://schemas.openxmlformats.org/drawingml/2006/main"/>
           <a:p xmlns:a="http://schemas.openxmlformats.org/drawingml/2006/main">
             <a:pPr algn="l">
+              <a:buNone/>
               <a:defRPr sz="900" b="0">
                 <a:solidFill>
                   <a:srgbClr val="667386"/>
@@ -5068,6 +5219,7 @@
           <a:lstStyle xmlns:a="http://schemas.openxmlformats.org/drawingml/2006/main"/>
           <a:p xmlns:a="http://schemas.openxmlformats.org/drawingml/2006/main">
             <a:pPr algn="r">
+              <a:buNone/>
               <a:defRPr sz="900" b="0">
                 <a:solidFill>
                   <a:srgbClr val="667386"/>
@@ -5087,14 +5239,14 @@
       </p:sp>
       <p:pic>
         <p:nvPicPr>
-          <p:cNvPr id="23" name=""/>
+          <p:cNvPr id="25" name=""/>
           <p:cNvPicPr>
             <a:picLocks xmlns:a="http://schemas.openxmlformats.org/drawingml/2006/main" noChangeAspect="1"/>
           </p:cNvPicPr>
           <p:nvPr/>
         </p:nvPicPr>
         <p:blipFill>
-          <a:blip xmlns:r="http://schemas.openxmlformats.org/officeDocument/2006/relationships" xmlns:a="http://schemas.openxmlformats.org/drawingml/2006/main" r:embed="Rd28fec54b2044c90"/>
+          <a:blip xmlns:r="http://schemas.openxmlformats.org/officeDocument/2006/relationships" xmlns:a="http://schemas.openxmlformats.org/drawingml/2006/main" r:embed="R28c559fb49be445e"/>
           <a:stretch xmlns:a="http://schemas.openxmlformats.org/drawingml/2006/main"/>
         </p:blipFill>
         <p:spPr>
@@ -5173,6 +5325,7 @@
           <a:lstStyle xmlns:a="http://schemas.openxmlformats.org/drawingml/2006/main"/>
           <a:p xmlns:a="http://schemas.openxmlformats.org/drawingml/2006/main">
             <a:pPr algn="ctr">
+              <a:buNone/>
               <a:defRPr sz="2550" b="1">
                 <a:solidFill>
                   <a:srgbClr val="B44738"/>
@@ -5223,6 +5376,7 @@
           <a:lstStyle xmlns:a="http://schemas.openxmlformats.org/drawingml/2006/main"/>
           <a:p xmlns:a="http://schemas.openxmlformats.org/drawingml/2006/main">
             <a:pPr algn="ctr">
+              <a:buNone/>
               <a:defRPr sz="1200" b="1">
                 <a:solidFill>
                   <a:srgbClr val="24364B"/>
@@ -5240,6 +5394,7 @@
           </a:p>
           <a:p xmlns:a="http://schemas.openxmlformats.org/drawingml/2006/main">
             <a:pPr algn="ctr">
+              <a:buNone/>
               <a:defRPr sz="1200" b="1">
                 <a:solidFill>
                   <a:srgbClr val="24364B"/>
@@ -5323,6 +5478,7 @@
           <a:lstStyle xmlns:a="http://schemas.openxmlformats.org/drawingml/2006/main"/>
           <a:p xmlns:a="http://schemas.openxmlformats.org/drawingml/2006/main">
             <a:pPr algn="ctr">
+              <a:buNone/>
               <a:defRPr sz="2400" b="1">
                 <a:solidFill>
                   <a:srgbClr val="24364B"/>
@@ -5373,6 +5529,7 @@
           <a:lstStyle xmlns:a="http://schemas.openxmlformats.org/drawingml/2006/main"/>
           <a:p xmlns:a="http://schemas.openxmlformats.org/drawingml/2006/main">
             <a:pPr algn="ctr">
+              <a:buNone/>
               <a:defRPr sz="1275" b="1">
                 <a:solidFill>
                   <a:srgbClr val="24364B"/>
@@ -5456,6 +5613,7 @@
           <a:lstStyle xmlns:a="http://schemas.openxmlformats.org/drawingml/2006/main"/>
           <a:p xmlns:a="http://schemas.openxmlformats.org/drawingml/2006/main">
             <a:pPr algn="ctr">
+              <a:buNone/>
               <a:defRPr sz="2325" b="1">
                 <a:solidFill>
                   <a:srgbClr val="24364B"/>
@@ -5506,6 +5664,7 @@
           <a:lstStyle xmlns:a="http://schemas.openxmlformats.org/drawingml/2006/main"/>
           <a:p xmlns:a="http://schemas.openxmlformats.org/drawingml/2006/main">
             <a:pPr algn="ctr">
+              <a:buNone/>
               <a:defRPr sz="1125" b="1">
                 <a:solidFill>
                   <a:srgbClr val="24364B"/>
@@ -5585,6 +5744,7 @@
           <a:lstStyle xmlns:a="http://schemas.openxmlformats.org/drawingml/2006/main"/>
           <a:p xmlns:a="http://schemas.openxmlformats.org/drawingml/2006/main">
             <a:pPr algn="l">
+              <a:buNone/>
               <a:defRPr sz="1050" b="1">
                 <a:solidFill>
                   <a:srgbClr val="667386"/>
@@ -5635,6 +5795,7 @@
           <a:lstStyle xmlns:a="http://schemas.openxmlformats.org/drawingml/2006/main"/>
           <a:p xmlns:a="http://schemas.openxmlformats.org/drawingml/2006/main">
             <a:pPr algn="l">
+              <a:buNone/>
               <a:defRPr sz="2700" b="1">
                 <a:solidFill>
                   <a:srgbClr val="000000"/>
@@ -5685,6 +5846,7 @@
           <a:lstStyle xmlns:a="http://schemas.openxmlformats.org/drawingml/2006/main"/>
           <a:p xmlns:a="http://schemas.openxmlformats.org/drawingml/2006/main">
             <a:pPr algn="l">
+              <a:buNone/>
               <a:defRPr sz="1350" b="0">
                 <a:solidFill>
                   <a:srgbClr val="667386"/>
@@ -5768,6 +5930,7 @@
           <a:lstStyle xmlns:a="http://schemas.openxmlformats.org/drawingml/2006/main"/>
           <a:p xmlns:a="http://schemas.openxmlformats.org/drawingml/2006/main">
             <a:pPr algn="l">
+              <a:buNone/>
               <a:defRPr sz="900" b="0">
                 <a:solidFill>
                   <a:srgbClr val="667386"/>
@@ -5818,6 +5981,7 @@
           <a:lstStyle xmlns:a="http://schemas.openxmlformats.org/drawingml/2006/main"/>
           <a:p xmlns:a="http://schemas.openxmlformats.org/drawingml/2006/main">
             <a:pPr algn="r">
+              <a:buNone/>
               <a:defRPr sz="900" b="0">
                 <a:solidFill>
                   <a:srgbClr val="667386"/>
@@ -5837,14 +6001,14 @@
       </p:sp>
       <p:pic>
         <p:nvPicPr>
-          <p:cNvPr id="14" name=""/>
+          <p:cNvPr id="16" name=""/>
           <p:cNvPicPr>
             <a:picLocks xmlns:a="http://schemas.openxmlformats.org/drawingml/2006/main" noChangeAspect="1"/>
           </p:cNvPicPr>
           <p:nvPr/>
         </p:nvPicPr>
         <p:blipFill>
-          <a:blip xmlns:r="http://schemas.openxmlformats.org/officeDocument/2006/relationships" xmlns:a="http://schemas.openxmlformats.org/drawingml/2006/main" r:embed="R0f9c8b5688b2450d"/>
+          <a:blip xmlns:r="http://schemas.openxmlformats.org/officeDocument/2006/relationships" xmlns:a="http://schemas.openxmlformats.org/drawingml/2006/main" r:embed="R0b1934c1b57542cd"/>
           <a:stretch xmlns:a="http://schemas.openxmlformats.org/drawingml/2006/main"/>
         </p:blipFill>
         <p:spPr>
@@ -5919,6 +6083,7 @@
           <a:lstStyle xmlns:a="http://schemas.openxmlformats.org/drawingml/2006/main"/>
           <a:p xmlns:a="http://schemas.openxmlformats.org/drawingml/2006/main">
             <a:pPr algn="l">
+              <a:buNone/>
               <a:defRPr sz="1050" b="1">
                 <a:solidFill>
                   <a:srgbClr val="667386"/>
@@ -5969,6 +6134,7 @@
           <a:lstStyle xmlns:a="http://schemas.openxmlformats.org/drawingml/2006/main"/>
           <a:p xmlns:a="http://schemas.openxmlformats.org/drawingml/2006/main">
             <a:pPr algn="l">
+              <a:buNone/>
               <a:defRPr sz="2700" b="1">
                 <a:solidFill>
                   <a:srgbClr val="000000"/>
@@ -6019,6 +6185,7 @@
           <a:lstStyle xmlns:a="http://schemas.openxmlformats.org/drawingml/2006/main"/>
           <a:p xmlns:a="http://schemas.openxmlformats.org/drawingml/2006/main">
             <a:pPr algn="l">
+              <a:buNone/>
               <a:defRPr sz="1350" b="0">
                 <a:solidFill>
                   <a:srgbClr val="667386"/>
@@ -6102,6 +6269,7 @@
           <a:lstStyle xmlns:a="http://schemas.openxmlformats.org/drawingml/2006/main"/>
           <a:p xmlns:a="http://schemas.openxmlformats.org/drawingml/2006/main">
             <a:pPr algn="l">
+              <a:buNone/>
               <a:defRPr sz="900" b="0">
                 <a:solidFill>
                   <a:srgbClr val="667386"/>
@@ -6152,6 +6320,7 @@
           <a:lstStyle xmlns:a="http://schemas.openxmlformats.org/drawingml/2006/main"/>
           <a:p xmlns:a="http://schemas.openxmlformats.org/drawingml/2006/main">
             <a:pPr algn="r">
+              <a:buNone/>
               <a:defRPr sz="900" b="0">
                 <a:solidFill>
                   <a:srgbClr val="667386"/>
@@ -6171,14 +6340,14 @@
       </p:sp>
       <p:pic>
         <p:nvPicPr>
-          <p:cNvPr id="20" name=""/>
+          <p:cNvPr id="22" name=""/>
           <p:cNvPicPr>
             <a:picLocks xmlns:a="http://schemas.openxmlformats.org/drawingml/2006/main" noChangeAspect="1"/>
           </p:cNvPicPr>
           <p:nvPr/>
         </p:nvPicPr>
         <p:blipFill>
-          <a:blip xmlns:r="http://schemas.openxmlformats.org/officeDocument/2006/relationships" xmlns:a="http://schemas.openxmlformats.org/drawingml/2006/main" r:embed="R5ce6a15e27694baa"/>
+          <a:blip xmlns:r="http://schemas.openxmlformats.org/officeDocument/2006/relationships" xmlns:a="http://schemas.openxmlformats.org/drawingml/2006/main" r:embed="R4b245006bf69432e"/>
           <a:stretch xmlns:a="http://schemas.openxmlformats.org/drawingml/2006/main"/>
         </p:blipFill>
         <p:spPr>
@@ -6257,6 +6426,7 @@
           <a:lstStyle xmlns:a="http://schemas.openxmlformats.org/drawingml/2006/main"/>
           <a:p xmlns:a="http://schemas.openxmlformats.org/drawingml/2006/main">
             <a:pPr algn="ctr">
+              <a:buNone/>
               <a:defRPr sz="2700" b="1">
                 <a:solidFill>
                   <a:srgbClr val="B44738"/>
@@ -6307,6 +6477,7 @@
           <a:lstStyle xmlns:a="http://schemas.openxmlformats.org/drawingml/2006/main"/>
           <a:p xmlns:a="http://schemas.openxmlformats.org/drawingml/2006/main">
             <a:pPr algn="ctr">
+              <a:buNone/>
               <a:defRPr sz="1200" b="1">
                 <a:solidFill>
                   <a:srgbClr val="24364B"/>
@@ -6324,6 +6495,7 @@
           </a:p>
           <a:p xmlns:a="http://schemas.openxmlformats.org/drawingml/2006/main">
             <a:pPr algn="ctr">
+              <a:buNone/>
               <a:defRPr sz="1200" b="1">
                 <a:solidFill>
                   <a:srgbClr val="24364B"/>
@@ -6407,6 +6579,7 @@
           <a:lstStyle xmlns:a="http://schemas.openxmlformats.org/drawingml/2006/main"/>
           <a:p xmlns:a="http://schemas.openxmlformats.org/drawingml/2006/main">
             <a:pPr algn="ctr">
+              <a:buNone/>
               <a:defRPr sz="2700" b="1">
                 <a:solidFill>
                   <a:srgbClr val="B44738"/>
@@ -6457,6 +6630,7 @@
           <a:lstStyle xmlns:a="http://schemas.openxmlformats.org/drawingml/2006/main"/>
           <a:p xmlns:a="http://schemas.openxmlformats.org/drawingml/2006/main">
             <a:pPr algn="ctr">
+              <a:buNone/>
               <a:defRPr sz="1200" b="1">
                 <a:solidFill>
                   <a:srgbClr val="24364B"/>
@@ -6474,6 +6648,7 @@
           </a:p>
           <a:p xmlns:a="http://schemas.openxmlformats.org/drawingml/2006/main">
             <a:pPr algn="ctr">
+              <a:buNone/>
               <a:defRPr sz="1200" b="1">
                 <a:solidFill>
                   <a:srgbClr val="24364B"/>
@@ -6553,6 +6728,7 @@
           <a:lstStyle xmlns:a="http://schemas.openxmlformats.org/drawingml/2006/main"/>
           <a:p xmlns:a="http://schemas.openxmlformats.org/drawingml/2006/main">
             <a:pPr algn="l">
+              <a:buNone/>
               <a:defRPr sz="1050" b="1">
                 <a:solidFill>
                   <a:srgbClr val="667386"/>
@@ -6603,6 +6779,7 @@
           <a:lstStyle xmlns:a="http://schemas.openxmlformats.org/drawingml/2006/main"/>
           <a:p xmlns:a="http://schemas.openxmlformats.org/drawingml/2006/main">
             <a:pPr algn="l">
+              <a:buNone/>
               <a:defRPr sz="2700" b="1">
                 <a:solidFill>
                   <a:srgbClr val="000000"/>
@@ -6653,6 +6830,7 @@
           <a:lstStyle xmlns:a="http://schemas.openxmlformats.org/drawingml/2006/main"/>
           <a:p xmlns:a="http://schemas.openxmlformats.org/drawingml/2006/main">
             <a:pPr algn="l">
+              <a:buNone/>
               <a:defRPr sz="1350" b="0">
                 <a:solidFill>
                   <a:srgbClr val="667386"/>
@@ -6736,6 +6914,7 @@
           <a:lstStyle xmlns:a="http://schemas.openxmlformats.org/drawingml/2006/main"/>
           <a:p xmlns:a="http://schemas.openxmlformats.org/drawingml/2006/main">
             <a:pPr algn="l">
+              <a:buNone/>
               <a:defRPr sz="900" b="0">
                 <a:solidFill>
                   <a:srgbClr val="667386"/>
@@ -6786,6 +6965,7 @@
           <a:lstStyle xmlns:a="http://schemas.openxmlformats.org/drawingml/2006/main"/>
           <a:p xmlns:a="http://schemas.openxmlformats.org/drawingml/2006/main">
             <a:pPr algn="r">
+              <a:buNone/>
               <a:defRPr sz="900" b="0">
                 <a:solidFill>
                   <a:srgbClr val="667386"/>
@@ -6869,6 +7049,7 @@
           <a:lstStyle xmlns:a="http://schemas.openxmlformats.org/drawingml/2006/main"/>
           <a:p xmlns:a="http://schemas.openxmlformats.org/drawingml/2006/main">
             <a:pPr algn="l">
+              <a:buNone/>
               <a:defRPr sz="1200" b="1">
                 <a:solidFill>
                   <a:srgbClr val="B44738"/>
@@ -6919,6 +7100,7 @@
           <a:lstStyle xmlns:a="http://schemas.openxmlformats.org/drawingml/2006/main"/>
           <a:p xmlns:a="http://schemas.openxmlformats.org/drawingml/2006/main">
             <a:pPr algn="l">
+              <a:buNone/>
               <a:defRPr sz="2325" b="1">
                 <a:solidFill>
                   <a:srgbClr val="000000"/>
@@ -7002,6 +7184,7 @@
           <a:lstStyle xmlns:a="http://schemas.openxmlformats.org/drawingml/2006/main"/>
           <a:p xmlns:a="http://schemas.openxmlformats.org/drawingml/2006/main">
             <a:pPr algn="l">
+              <a:buNone/>
               <a:defRPr sz="1500" b="0">
                 <a:solidFill>
                   <a:srgbClr val="24364B"/>
@@ -7085,6 +7268,7 @@
           <a:lstStyle xmlns:a="http://schemas.openxmlformats.org/drawingml/2006/main"/>
           <a:p xmlns:a="http://schemas.openxmlformats.org/drawingml/2006/main">
             <a:pPr algn="l">
+              <a:buNone/>
               <a:defRPr sz="1500" b="0">
                 <a:solidFill>
                   <a:srgbClr val="24364B"/>
@@ -7168,6 +7352,7 @@
           <a:lstStyle xmlns:a="http://schemas.openxmlformats.org/drawingml/2006/main"/>
           <a:p xmlns:a="http://schemas.openxmlformats.org/drawingml/2006/main">
             <a:pPr algn="l">
+              <a:buNone/>
               <a:defRPr sz="1200" b="1">
                 <a:solidFill>
                   <a:srgbClr val="3D8DFF"/>
@@ -7218,6 +7403,7 @@
           <a:lstStyle xmlns:a="http://schemas.openxmlformats.org/drawingml/2006/main"/>
           <a:p xmlns:a="http://schemas.openxmlformats.org/drawingml/2006/main">
             <a:pPr algn="l">
+              <a:buNone/>
               <a:defRPr sz="2325" b="1">
                 <a:solidFill>
                   <a:srgbClr val="000000"/>
@@ -7301,6 +7487,7 @@
           <a:lstStyle xmlns:a="http://schemas.openxmlformats.org/drawingml/2006/main"/>
           <a:p xmlns:a="http://schemas.openxmlformats.org/drawingml/2006/main">
             <a:pPr algn="l">
+              <a:buNone/>
               <a:defRPr sz="1500" b="0">
                 <a:solidFill>
                   <a:srgbClr val="24364B"/>
@@ -7384,6 +7571,7 @@
           <a:lstStyle xmlns:a="http://schemas.openxmlformats.org/drawingml/2006/main"/>
           <a:p xmlns:a="http://schemas.openxmlformats.org/drawingml/2006/main">
             <a:pPr algn="l">
+              <a:buNone/>
               <a:defRPr sz="1500" b="0">
                 <a:solidFill>
                   <a:srgbClr val="24364B"/>
@@ -7467,6 +7655,7 @@
           <a:lstStyle xmlns:a="http://schemas.openxmlformats.org/drawingml/2006/main"/>
           <a:p xmlns:a="http://schemas.openxmlformats.org/drawingml/2006/main">
             <a:pPr algn="l">
+              <a:buNone/>
               <a:defRPr sz="1125" b="1">
                 <a:solidFill>
                   <a:srgbClr val="D0EDFA"/>
@@ -7517,6 +7706,7 @@
           <a:lstStyle xmlns:a="http://schemas.openxmlformats.org/drawingml/2006/main"/>
           <a:p xmlns:a="http://schemas.openxmlformats.org/drawingml/2006/main">
             <a:pPr algn="l">
+              <a:buNone/>
               <a:defRPr sz="1575" b="1">
                 <a:solidFill>
                   <a:srgbClr val="FFFFFF"/>
@@ -7530,6 +7720,1064 @@
                 </a:solidFill>
               </a:rPr>
               <a:t>Quantify the pre-outcome features that separate these event environments—starting with breach severity and calendar timing, then carefully chosen asset traits.</a:t>
+            </a:r>
+          </a:p>
+        </p:txBody>
+      </p:sp>
+    </p:spTree>
+    <p:extLst>
+      <p:ext uri="{BB962C8B-B14F-4D97-AF65-F5344CB8AC3E}">
+        <p14:creationId xmlns:p14="http://schemas.microsoft.com/office/powerpoint/2010/main" val="1921121433"/>
+      </p:ext>
+    </p:extLst>
+  </p:cSld>
+</p:sld>
+</file>
+
+<file path=ppt/slides/slide8.xml><?xml version="1.0" encoding="utf-8"?>
+<p:sld xmlns:p="http://schemas.openxmlformats.org/presentationml/2006/main">
+  <p:cSld>
+    <p:bg>
+      <p:bgPr>
+        <a:solidFill xmlns:a="http://schemas.openxmlformats.org/drawingml/2006/main">
+          <a:srgbClr val="FFFFFF"/>
+        </a:solidFill>
+      </p:bgPr>
+    </p:bg>
+    <p:spTree>
+      <p:nvGrpSpPr>
+        <p:cNvPr id="1" name=""/>
+        <p:cNvGrpSpPr/>
+        <p:nvPr/>
+      </p:nvGrpSpPr>
+      <p:grpSpPr>
+        <a:xfrm xmlns:a="http://schemas.openxmlformats.org/drawingml/2006/main"/>
+      </p:grpSpPr>
+      <p:sp>
+        <p:nvSpPr>
+          <p:cNvPr id="24" name="section-label">
+            <a:extLst xmlns:a="http://schemas.openxmlformats.org/drawingml/2006/main">
+              <a:ext uri="{FF2B5EF4-FFF2-40B4-BE49-F238E27FC236}">
+                <a16:creationId xmlns:a16="http://schemas.microsoft.com/office/drawing/2014/main" id="{8D3D936E-7B4F-4540-BD4F-8A6D6B2BBA10}"/>
+              </a:ext>
+            </a:extLst>
+          </p:cNvPr>
+          <p:cNvSpPr>
+            <a:spLocks xmlns:a="http://schemas.openxmlformats.org/drawingml/2006/main" noGrp="1"/>
+          </p:cNvSpPr>
+          <p:nvPr/>
+        </p:nvSpPr>
+        <p:spPr>
+          <a:xfrm xmlns:a="http://schemas.openxmlformats.org/drawingml/2006/main">
+            <a:off x="400050" y="228600"/>
+            <a:ext cx="4286250" cy="190500"/>
+          </a:xfrm>
+          <a:prstGeom xmlns:a="http://schemas.openxmlformats.org/drawingml/2006/main" prst="rect">
+            <a:avLst/>
+          </a:prstGeom>
+          <a:noFill xmlns:a="http://schemas.openxmlformats.org/drawingml/2006/main"/>
+          <a:ln xmlns:a="http://schemas.openxmlformats.org/drawingml/2006/main" w="0">
+            <a:noFill/>
+            <a:prstDash val="solid"/>
+          </a:ln>
+        </p:spPr>
+        <p:txBody>
+          <a:bodyPr xmlns:a="http://schemas.openxmlformats.org/drawingml/2006/main" anchor="t"/>
+          <a:lstStyle xmlns:a="http://schemas.openxmlformats.org/drawingml/2006/main"/>
+          <a:p xmlns:a="http://schemas.openxmlformats.org/drawingml/2006/main">
+            <a:pPr algn="l">
+              <a:buNone/>
+              <a:defRPr sz="1050" b="1">
+                <a:solidFill>
+                  <a:srgbClr val="667386"/>
+                </a:solidFill>
+              </a:defRPr>
+            </a:pPr>
+            <a:r>
+              <a:rPr sz="1050" b="1">
+                <a:solidFill>
+                  <a:srgbClr val="667386"/>
+                </a:solidFill>
+              </a:rPr>
+              <a:t>EDGE DISCOVERY LAB · EDL-MS-01</a:t>
+            </a:r>
+          </a:p>
+        </p:txBody>
+      </p:sp>
+      <p:sp>
+        <p:nvSpPr>
+          <p:cNvPr id="2" name="slide-title">
+            <a:extLst xmlns:a="http://schemas.openxmlformats.org/drawingml/2006/main">
+              <a:ext uri="{FF2B5EF4-FFF2-40B4-BE49-F238E27FC236}">
+                <a16:creationId xmlns:a16="http://schemas.microsoft.com/office/drawing/2014/main" id="{760E151D-53E4-4A2E-82D8-BA269F7D1BE2}"/>
+              </a:ext>
+            </a:extLst>
+          </p:cNvPr>
+          <p:cNvSpPr>
+            <a:spLocks xmlns:a="http://schemas.openxmlformats.org/drawingml/2006/main" noGrp="1"/>
+          </p:cNvSpPr>
+          <p:nvPr/>
+        </p:nvSpPr>
+        <p:spPr>
+          <a:xfrm xmlns:a="http://schemas.openxmlformats.org/drawingml/2006/main">
+            <a:off x="400050" y="504825"/>
+            <a:ext cx="11334750" cy="514350"/>
+          </a:xfrm>
+          <a:prstGeom xmlns:a="http://schemas.openxmlformats.org/drawingml/2006/main" prst="rect">
+            <a:avLst/>
+          </a:prstGeom>
+          <a:noFill xmlns:a="http://schemas.openxmlformats.org/drawingml/2006/main"/>
+          <a:ln xmlns:a="http://schemas.openxmlformats.org/drawingml/2006/main" w="0">
+            <a:noFill/>
+            <a:prstDash val="solid"/>
+          </a:ln>
+        </p:spPr>
+        <p:txBody>
+          <a:bodyPr xmlns:a="http://schemas.openxmlformats.org/drawingml/2006/main" anchor="t"/>
+          <a:lstStyle xmlns:a="http://schemas.openxmlformats.org/drawingml/2006/main"/>
+          <a:p xmlns:a="http://schemas.openxmlformats.org/drawingml/2006/main">
+            <a:pPr algn="l">
+              <a:buNone/>
+              <a:defRPr sz="2700" b="1">
+                <a:solidFill>
+                  <a:srgbClr val="000000"/>
+                </a:solidFill>
+              </a:defRPr>
+            </a:pPr>
+            <a:r>
+              <a:rPr sz="2700" b="1">
+                <a:solidFill>
+                  <a:srgbClr val="000000"/>
+                </a:solidFill>
+              </a:rPr>
+              <a:t>Rule 201, in plain English: the rebound clue did not generalize</a:t>
+            </a:r>
+          </a:p>
+        </p:txBody>
+      </p:sp>
+      <p:sp>
+        <p:nvSpPr>
+          <p:cNvPr id="3" name="slide-subtitle">
+            <a:extLst xmlns:a="http://schemas.openxmlformats.org/drawingml/2006/main">
+              <a:ext uri="{FF2B5EF4-FFF2-40B4-BE49-F238E27FC236}">
+                <a16:creationId xmlns:a16="http://schemas.microsoft.com/office/drawing/2014/main" id="{9F6C7ABB-F628-4F67-B017-5D026A0F67CA}"/>
+              </a:ext>
+            </a:extLst>
+          </p:cNvPr>
+          <p:cNvSpPr>
+            <a:spLocks xmlns:a="http://schemas.openxmlformats.org/drawingml/2006/main" noGrp="1"/>
+          </p:cNvSpPr>
+          <p:nvPr/>
+        </p:nvSpPr>
+        <p:spPr>
+          <a:xfrm xmlns:a="http://schemas.openxmlformats.org/drawingml/2006/main">
+            <a:off x="419100" y="1028700"/>
+            <a:ext cx="11049000" cy="285750"/>
+          </a:xfrm>
+          <a:prstGeom xmlns:a="http://schemas.openxmlformats.org/drawingml/2006/main" prst="rect">
+            <a:avLst/>
+          </a:prstGeom>
+          <a:noFill xmlns:a="http://schemas.openxmlformats.org/drawingml/2006/main"/>
+          <a:ln xmlns:a="http://schemas.openxmlformats.org/drawingml/2006/main" w="0">
+            <a:noFill/>
+            <a:prstDash val="solid"/>
+          </a:ln>
+        </p:spPr>
+        <p:txBody>
+          <a:bodyPr xmlns:a="http://schemas.openxmlformats.org/drawingml/2006/main" anchor="t"/>
+          <a:lstStyle xmlns:a="http://schemas.openxmlformats.org/drawingml/2006/main"/>
+          <a:p xmlns:a="http://schemas.openxmlformats.org/drawingml/2006/main">
+            <a:pPr algn="l">
+              <a:buNone/>
+              <a:defRPr sz="1350" b="0">
+                <a:solidFill>
+                  <a:srgbClr val="667386"/>
+                </a:solidFill>
+              </a:defRPr>
+            </a:pPr>
+            <a:r>
+              <a:rPr sz="1350" b="0">
+                <a:solidFill>
+                  <a:srgbClr val="667386"/>
+                </a:solidFill>
+              </a:rPr>
+              <a:t>The study improved our diagnosis without producing a tradable rule.</a:t>
+            </a:r>
+          </a:p>
+        </p:txBody>
+      </p:sp>
+      <p:sp>
+        <p:nvSpPr>
+          <p:cNvPr id="4" name="">
+            <a:extLst xmlns:a="http://schemas.openxmlformats.org/drawingml/2006/main">
+              <a:ext uri="{FF2B5EF4-FFF2-40B4-BE49-F238E27FC236}">
+                <a16:creationId xmlns:a16="http://schemas.microsoft.com/office/drawing/2014/main" id="{32EA391F-0735-43D7-8C52-FF0BA3203881}"/>
+              </a:ext>
+            </a:extLst>
+          </p:cNvPr>
+          <p:cNvSpPr>
+            <a:spLocks xmlns:a="http://schemas.openxmlformats.org/drawingml/2006/main" noGrp="1"/>
+          </p:cNvSpPr>
+          <p:nvPr/>
+        </p:nvSpPr>
+        <p:spPr>
+          <a:xfrm xmlns:a="http://schemas.openxmlformats.org/drawingml/2006/main">
+            <a:off x="400050" y="1362075"/>
+            <a:ext cx="11391900" cy="19050"/>
+          </a:xfrm>
+          <a:prstGeom xmlns:a="http://schemas.openxmlformats.org/drawingml/2006/main" prst="rect">
+            <a:avLst/>
+          </a:prstGeom>
+          <a:solidFill xmlns:a="http://schemas.openxmlformats.org/drawingml/2006/main">
+            <a:srgbClr val="B8BCC4"/>
+          </a:solidFill>
+          <a:ln xmlns:a="http://schemas.openxmlformats.org/drawingml/2006/main" w="0">
+            <a:solidFill>
+              <a:srgbClr val="B8BCC4"/>
+            </a:solidFill>
+            <a:prstDash val="solid"/>
+          </a:ln>
+        </p:spPr>
+      </p:sp>
+      <p:sp>
+        <p:nvSpPr>
+          <p:cNvPr id="5" name="footer-status">
+            <a:extLst xmlns:a="http://schemas.openxmlformats.org/drawingml/2006/main">
+              <a:ext uri="{FF2B5EF4-FFF2-40B4-BE49-F238E27FC236}">
+                <a16:creationId xmlns:a16="http://schemas.microsoft.com/office/drawing/2014/main" id="{34C68D2D-E3EB-41D0-A8B8-08CFE6F93437}"/>
+              </a:ext>
+            </a:extLst>
+          </p:cNvPr>
+          <p:cNvSpPr>
+            <a:spLocks xmlns:a="http://schemas.openxmlformats.org/drawingml/2006/main" noGrp="1"/>
+          </p:cNvSpPr>
+          <p:nvPr/>
+        </p:nvSpPr>
+        <p:spPr>
+          <a:xfrm xmlns:a="http://schemas.openxmlformats.org/drawingml/2006/main">
+            <a:off x="400050" y="6515100"/>
+            <a:ext cx="6191250" cy="171450"/>
+          </a:xfrm>
+          <a:prstGeom xmlns:a="http://schemas.openxmlformats.org/drawingml/2006/main" prst="rect">
+            <a:avLst/>
+          </a:prstGeom>
+          <a:noFill xmlns:a="http://schemas.openxmlformats.org/drawingml/2006/main"/>
+          <a:ln xmlns:a="http://schemas.openxmlformats.org/drawingml/2006/main" w="0">
+            <a:noFill/>
+            <a:prstDash val="solid"/>
+          </a:ln>
+        </p:spPr>
+        <p:txBody>
+          <a:bodyPr xmlns:a="http://schemas.openxmlformats.org/drawingml/2006/main" anchor="t"/>
+          <a:lstStyle xmlns:a="http://schemas.openxmlformats.org/drawingml/2006/main"/>
+          <a:p xmlns:a="http://schemas.openxmlformats.org/drawingml/2006/main">
+            <a:pPr algn="l">
+              <a:buNone/>
+              <a:defRPr sz="900" b="0">
+                <a:solidFill>
+                  <a:srgbClr val="667386"/>
+                </a:solidFill>
+              </a:defRPr>
+            </a:pPr>
+            <a:r>
+              <a:rPr sz="900" b="0">
+                <a:solidFill>
+                  <a:srgbClr val="667386"/>
+                </a:solidFill>
+              </a:rPr>
+              <a:t>Adjusted daily · 2018–2023 TRAIN · matched falsification</a:t>
+            </a:r>
+          </a:p>
+        </p:txBody>
+      </p:sp>
+      <p:sp>
+        <p:nvSpPr>
+          <p:cNvPr id="6" name="page-number">
+            <a:extLst xmlns:a="http://schemas.openxmlformats.org/drawingml/2006/main">
+              <a:ext uri="{FF2B5EF4-FFF2-40B4-BE49-F238E27FC236}">
+                <a16:creationId xmlns:a16="http://schemas.microsoft.com/office/drawing/2014/main" id="{A1804F29-8A04-44B9-9AA4-3E86E06ED8AC}"/>
+              </a:ext>
+            </a:extLst>
+          </p:cNvPr>
+          <p:cNvSpPr>
+            <a:spLocks xmlns:a="http://schemas.openxmlformats.org/drawingml/2006/main" noGrp="1"/>
+          </p:cNvSpPr>
+          <p:nvPr/>
+        </p:nvSpPr>
+        <p:spPr>
+          <a:xfrm xmlns:a="http://schemas.openxmlformats.org/drawingml/2006/main">
+            <a:off x="11049000" y="6496050"/>
+            <a:ext cx="723900" cy="171450"/>
+          </a:xfrm>
+          <a:prstGeom xmlns:a="http://schemas.openxmlformats.org/drawingml/2006/main" prst="rect">
+            <a:avLst/>
+          </a:prstGeom>
+          <a:noFill xmlns:a="http://schemas.openxmlformats.org/drawingml/2006/main"/>
+          <a:ln xmlns:a="http://schemas.openxmlformats.org/drawingml/2006/main" w="0">
+            <a:noFill/>
+            <a:prstDash val="solid"/>
+          </a:ln>
+        </p:spPr>
+        <p:txBody>
+          <a:bodyPr xmlns:a="http://schemas.openxmlformats.org/drawingml/2006/main" anchor="t"/>
+          <a:lstStyle xmlns:a="http://schemas.openxmlformats.org/drawingml/2006/main"/>
+          <a:p xmlns:a="http://schemas.openxmlformats.org/drawingml/2006/main">
+            <a:pPr algn="r">
+              <a:buNone/>
+              <a:defRPr sz="900" b="0">
+                <a:solidFill>
+                  <a:srgbClr val="667386"/>
+                </a:solidFill>
+              </a:defRPr>
+            </a:pPr>
+            <a:r>
+              <a:rPr sz="900" b="0">
+                <a:solidFill>
+                  <a:srgbClr val="667386"/>
+                </a:solidFill>
+              </a:rPr>
+              <a:t>08</a:t>
+            </a:r>
+          </a:p>
+        </p:txBody>
+      </p:sp>
+      <p:sp>
+        <p:nvSpPr>
+          <p:cNvPr id="7" name="">
+            <a:extLst xmlns:a="http://schemas.openxmlformats.org/drawingml/2006/main">
+              <a:ext uri="{FF2B5EF4-FFF2-40B4-BE49-F238E27FC236}">
+                <a16:creationId xmlns:a16="http://schemas.microsoft.com/office/drawing/2014/main" id="{090EE5A6-8004-4E4D-A80B-0CE4278AAD2F}"/>
+              </a:ext>
+            </a:extLst>
+          </p:cNvPr>
+          <p:cNvSpPr>
+            <a:spLocks xmlns:a="http://schemas.openxmlformats.org/drawingml/2006/main" noGrp="1"/>
+          </p:cNvSpPr>
+          <p:nvPr/>
+        </p:nvSpPr>
+        <p:spPr>
+          <a:xfrm xmlns:a="http://schemas.openxmlformats.org/drawingml/2006/main">
+            <a:off x="495300" y="1733550"/>
+            <a:ext cx="5334000" cy="3105150"/>
+          </a:xfrm>
+          <a:prstGeom xmlns:a="http://schemas.openxmlformats.org/drawingml/2006/main" prst="rect">
+            <a:avLst/>
+          </a:prstGeom>
+          <a:solidFill xmlns:a="http://schemas.openxmlformats.org/drawingml/2006/main">
+            <a:srgbClr val="F6E5E1"/>
+          </a:solidFill>
+          <a:ln xmlns:a="http://schemas.openxmlformats.org/drawingml/2006/main" w="0">
+            <a:solidFill>
+              <a:srgbClr val="F6E5E1"/>
+            </a:solidFill>
+            <a:prstDash val="solid"/>
+          </a:ln>
+        </p:spPr>
+      </p:sp>
+      <p:sp>
+        <p:nvSpPr>
+          <p:cNvPr id="8" name="">
+            <a:extLst xmlns:a="http://schemas.openxmlformats.org/drawingml/2006/main">
+              <a:ext uri="{FF2B5EF4-FFF2-40B4-BE49-F238E27FC236}">
+                <a16:creationId xmlns:a16="http://schemas.microsoft.com/office/drawing/2014/main" id="{3F1ADD9B-1E73-47E0-AA71-8DAED2D61E72}"/>
+              </a:ext>
+            </a:extLst>
+          </p:cNvPr>
+          <p:cNvSpPr>
+            <a:spLocks xmlns:a="http://schemas.openxmlformats.org/drawingml/2006/main" noGrp="1"/>
+          </p:cNvSpPr>
+          <p:nvPr/>
+        </p:nvSpPr>
+        <p:spPr>
+          <a:xfrm xmlns:a="http://schemas.openxmlformats.org/drawingml/2006/main">
+            <a:off x="781050" y="2038350"/>
+            <a:ext cx="3429000" cy="228600"/>
+          </a:xfrm>
+          <a:prstGeom xmlns:a="http://schemas.openxmlformats.org/drawingml/2006/main" prst="rect">
+            <a:avLst/>
+          </a:prstGeom>
+          <a:noFill xmlns:a="http://schemas.openxmlformats.org/drawingml/2006/main"/>
+          <a:ln xmlns:a="http://schemas.openxmlformats.org/drawingml/2006/main" w="0">
+            <a:noFill/>
+            <a:prstDash val="solid"/>
+          </a:ln>
+        </p:spPr>
+        <p:txBody>
+          <a:bodyPr xmlns:a="http://schemas.openxmlformats.org/drawingml/2006/main" anchor="t"/>
+          <a:lstStyle xmlns:a="http://schemas.openxmlformats.org/drawingml/2006/main"/>
+          <a:p xmlns:a="http://schemas.openxmlformats.org/drawingml/2006/main">
+            <a:pPr algn="l">
+              <a:buNone/>
+              <a:defRPr sz="1200" b="1">
+                <a:solidFill>
+                  <a:srgbClr val="B44738"/>
+                </a:solidFill>
+              </a:defRPr>
+            </a:pPr>
+            <a:r>
+              <a:rPr sz="1200" b="1">
+                <a:solidFill>
+                  <a:srgbClr val="B44738"/>
+                </a:solidFill>
+              </a:rPr>
+              <a:t>THE STORY</a:t>
+            </a:r>
+          </a:p>
+        </p:txBody>
+      </p:sp>
+      <p:sp>
+        <p:nvSpPr>
+          <p:cNvPr id="9" name="">
+            <a:extLst xmlns:a="http://schemas.openxmlformats.org/drawingml/2006/main">
+              <a:ext uri="{FF2B5EF4-FFF2-40B4-BE49-F238E27FC236}">
+                <a16:creationId xmlns:a16="http://schemas.microsoft.com/office/drawing/2014/main" id="{B65C04A5-FAB1-4A3F-8A6F-35F10E071C19}"/>
+              </a:ext>
+            </a:extLst>
+          </p:cNvPr>
+          <p:cNvSpPr>
+            <a:spLocks xmlns:a="http://schemas.openxmlformats.org/drawingml/2006/main" noGrp="1"/>
+          </p:cNvSpPr>
+          <p:nvPr/>
+        </p:nvSpPr>
+        <p:spPr>
+          <a:xfrm xmlns:a="http://schemas.openxmlformats.org/drawingml/2006/main">
+            <a:off x="781050" y="2457450"/>
+            <a:ext cx="4533900" cy="704850"/>
+          </a:xfrm>
+          <a:prstGeom xmlns:a="http://schemas.openxmlformats.org/drawingml/2006/main" prst="rect">
+            <a:avLst/>
+          </a:prstGeom>
+          <a:noFill xmlns:a="http://schemas.openxmlformats.org/drawingml/2006/main"/>
+          <a:ln xmlns:a="http://schemas.openxmlformats.org/drawingml/2006/main" w="0">
+            <a:noFill/>
+            <a:prstDash val="solid"/>
+          </a:ln>
+        </p:spPr>
+        <p:txBody>
+          <a:bodyPr xmlns:a="http://schemas.openxmlformats.org/drawingml/2006/main" anchor="t"/>
+          <a:lstStyle xmlns:a="http://schemas.openxmlformats.org/drawingml/2006/main"/>
+          <a:p xmlns:a="http://schemas.openxmlformats.org/drawingml/2006/main">
+            <a:pPr algn="l">
+              <a:buNone/>
+              <a:defRPr sz="2325" b="1">
+                <a:solidFill>
+                  <a:srgbClr val="000000"/>
+                </a:solidFill>
+              </a:defRPr>
+            </a:pPr>
+            <a:r>
+              <a:rPr sz="2325" b="1">
+                <a:solidFill>
+                  <a:srgbClr val="000000"/>
+                </a:solidFill>
+              </a:rPr>
+              <a:t>A dramatic drop and strong close looked promising.</a:t>
+            </a:r>
+          </a:p>
+        </p:txBody>
+      </p:sp>
+      <p:sp>
+        <p:nvSpPr>
+          <p:cNvPr id="10" name="">
+            <a:extLst xmlns:a="http://schemas.openxmlformats.org/drawingml/2006/main">
+              <a:ext uri="{FF2B5EF4-FFF2-40B4-BE49-F238E27FC236}">
+                <a16:creationId xmlns:a16="http://schemas.microsoft.com/office/drawing/2014/main" id="{146DC260-8A28-4682-AECD-BF7E8DD1D978}"/>
+              </a:ext>
+            </a:extLst>
+          </p:cNvPr>
+          <p:cNvSpPr>
+            <a:spLocks xmlns:a="http://schemas.openxmlformats.org/drawingml/2006/main" noGrp="1"/>
+          </p:cNvSpPr>
+          <p:nvPr/>
+        </p:nvSpPr>
+        <p:spPr>
+          <a:xfrm xmlns:a="http://schemas.openxmlformats.org/drawingml/2006/main">
+            <a:off x="800100" y="3562350"/>
+            <a:ext cx="85725" cy="85725"/>
+          </a:xfrm>
+          <a:prstGeom xmlns:a="http://schemas.openxmlformats.org/drawingml/2006/main" prst="rect">
+            <a:avLst/>
+          </a:prstGeom>
+          <a:solidFill xmlns:a="http://schemas.openxmlformats.org/drawingml/2006/main">
+            <a:srgbClr val="B44738"/>
+          </a:solidFill>
+          <a:ln xmlns:a="http://schemas.openxmlformats.org/drawingml/2006/main" w="0">
+            <a:solidFill>
+              <a:srgbClr val="B44738"/>
+            </a:solidFill>
+            <a:prstDash val="solid"/>
+          </a:ln>
+        </p:spPr>
+      </p:sp>
+      <p:sp>
+        <p:nvSpPr>
+          <p:cNvPr id="11" name="">
+            <a:extLst xmlns:a="http://schemas.openxmlformats.org/drawingml/2006/main">
+              <a:ext uri="{FF2B5EF4-FFF2-40B4-BE49-F238E27FC236}">
+                <a16:creationId xmlns:a16="http://schemas.microsoft.com/office/drawing/2014/main" id="{86DF66A6-4FC1-47D2-90E3-DC49FF05FB69}"/>
+              </a:ext>
+            </a:extLst>
+          </p:cNvPr>
+          <p:cNvSpPr>
+            <a:spLocks xmlns:a="http://schemas.openxmlformats.org/drawingml/2006/main" noGrp="1"/>
+          </p:cNvSpPr>
+          <p:nvPr/>
+        </p:nvSpPr>
+        <p:spPr>
+          <a:xfrm xmlns:a="http://schemas.openxmlformats.org/drawingml/2006/main">
+            <a:off x="1009650" y="3486150"/>
+            <a:ext cx="4267200" cy="457200"/>
+          </a:xfrm>
+          <a:prstGeom xmlns:a="http://schemas.openxmlformats.org/drawingml/2006/main" prst="rect">
+            <a:avLst/>
+          </a:prstGeom>
+          <a:noFill xmlns:a="http://schemas.openxmlformats.org/drawingml/2006/main"/>
+          <a:ln xmlns:a="http://schemas.openxmlformats.org/drawingml/2006/main" w="0">
+            <a:noFill/>
+            <a:prstDash val="solid"/>
+          </a:ln>
+        </p:spPr>
+        <p:txBody>
+          <a:bodyPr xmlns:a="http://schemas.openxmlformats.org/drawingml/2006/main" anchor="t"/>
+          <a:lstStyle xmlns:a="http://schemas.openxmlformats.org/drawingml/2006/main"/>
+          <a:p xmlns:a="http://schemas.openxmlformats.org/drawingml/2006/main">
+            <a:pPr algn="l">
+              <a:buNone/>
+              <a:defRPr sz="1500" b="0">
+                <a:solidFill>
+                  <a:srgbClr val="24364B"/>
+                </a:solidFill>
+              </a:defRPr>
+            </a:pPr>
+            <a:r>
+              <a:rPr sz="1500" b="0">
+                <a:solidFill>
+                  <a:srgbClr val="24364B"/>
+                </a:solidFill>
+              </a:rPr>
+              <a:t>Pilot: median rebound near +3.7% by session five.</a:t>
+            </a:r>
+          </a:p>
+        </p:txBody>
+      </p:sp>
+      <p:sp>
+        <p:nvSpPr>
+          <p:cNvPr id="12" name="">
+            <a:extLst xmlns:a="http://schemas.openxmlformats.org/drawingml/2006/main">
+              <a:ext uri="{FF2B5EF4-FFF2-40B4-BE49-F238E27FC236}">
+                <a16:creationId xmlns:a16="http://schemas.microsoft.com/office/drawing/2014/main" id="{4928381F-738D-4ED3-9696-42E765FB3703}"/>
+              </a:ext>
+            </a:extLst>
+          </p:cNvPr>
+          <p:cNvSpPr>
+            <a:spLocks xmlns:a="http://schemas.openxmlformats.org/drawingml/2006/main" noGrp="1"/>
+          </p:cNvSpPr>
+          <p:nvPr/>
+        </p:nvSpPr>
+        <p:spPr>
+          <a:xfrm xmlns:a="http://schemas.openxmlformats.org/drawingml/2006/main">
+            <a:off x="800100" y="4133850"/>
+            <a:ext cx="85725" cy="85725"/>
+          </a:xfrm>
+          <a:prstGeom xmlns:a="http://schemas.openxmlformats.org/drawingml/2006/main" prst="rect">
+            <a:avLst/>
+          </a:prstGeom>
+          <a:solidFill xmlns:a="http://schemas.openxmlformats.org/drawingml/2006/main">
+            <a:srgbClr val="B44738"/>
+          </a:solidFill>
+          <a:ln xmlns:a="http://schemas.openxmlformats.org/drawingml/2006/main" w="0">
+            <a:solidFill>
+              <a:srgbClr val="B44738"/>
+            </a:solidFill>
+            <a:prstDash val="solid"/>
+          </a:ln>
+        </p:spPr>
+      </p:sp>
+      <p:sp>
+        <p:nvSpPr>
+          <p:cNvPr id="13" name="">
+            <a:extLst xmlns:a="http://schemas.openxmlformats.org/drawingml/2006/main">
+              <a:ext uri="{FF2B5EF4-FFF2-40B4-BE49-F238E27FC236}">
+                <a16:creationId xmlns:a16="http://schemas.microsoft.com/office/drawing/2014/main" id="{E09BB7C6-3C22-49D0-9DD0-5F83D9976B5A}"/>
+              </a:ext>
+            </a:extLst>
+          </p:cNvPr>
+          <p:cNvSpPr>
+            <a:spLocks xmlns:a="http://schemas.openxmlformats.org/drawingml/2006/main" noGrp="1"/>
+          </p:cNvSpPr>
+          <p:nvPr/>
+        </p:nvSpPr>
+        <p:spPr>
+          <a:xfrm xmlns:a="http://schemas.openxmlformats.org/drawingml/2006/main">
+            <a:off x="1009650" y="4057650"/>
+            <a:ext cx="4267200" cy="457200"/>
+          </a:xfrm>
+          <a:prstGeom xmlns:a="http://schemas.openxmlformats.org/drawingml/2006/main" prst="rect">
+            <a:avLst/>
+          </a:prstGeom>
+          <a:noFill xmlns:a="http://schemas.openxmlformats.org/drawingml/2006/main"/>
+          <a:ln xmlns:a="http://schemas.openxmlformats.org/drawingml/2006/main" w="0">
+            <a:noFill/>
+            <a:prstDash val="solid"/>
+          </a:ln>
+        </p:spPr>
+        <p:txBody>
+          <a:bodyPr xmlns:a="http://schemas.openxmlformats.org/drawingml/2006/main" anchor="t"/>
+          <a:lstStyle xmlns:a="http://schemas.openxmlformats.org/drawingml/2006/main"/>
+          <a:p xmlns:a="http://schemas.openxmlformats.org/drawingml/2006/main">
+            <a:pPr algn="l">
+              <a:buNone/>
+              <a:defRPr sz="1500" b="0">
+                <a:solidFill>
+                  <a:srgbClr val="24364B"/>
+                </a:solidFill>
+              </a:defRPr>
+            </a:pPr>
+            <a:r>
+              <a:rPr sz="1500" b="0">
+                <a:solidFill>
+                  <a:srgbClr val="24364B"/>
+                </a:solidFill>
+              </a:rPr>
+              <a:t>Balanced 88-stock core: roughly −0.24%.</a:t>
+            </a:r>
+          </a:p>
+        </p:txBody>
+      </p:sp>
+      <p:sp>
+        <p:nvSpPr>
+          <p:cNvPr id="14" name="">
+            <a:extLst xmlns:a="http://schemas.openxmlformats.org/drawingml/2006/main">
+              <a:ext uri="{FF2B5EF4-FFF2-40B4-BE49-F238E27FC236}">
+                <a16:creationId xmlns:a16="http://schemas.microsoft.com/office/drawing/2014/main" id="{A9940335-0CCC-4F4F-A5A6-EBD0D2D36CBB}"/>
+              </a:ext>
+            </a:extLst>
+          </p:cNvPr>
+          <p:cNvSpPr>
+            <a:spLocks xmlns:a="http://schemas.openxmlformats.org/drawingml/2006/main" noGrp="1"/>
+          </p:cNvSpPr>
+          <p:nvPr/>
+        </p:nvSpPr>
+        <p:spPr>
+          <a:xfrm xmlns:a="http://schemas.openxmlformats.org/drawingml/2006/main">
+            <a:off x="6153150" y="1733550"/>
+            <a:ext cx="5543550" cy="3105150"/>
+          </a:xfrm>
+          <a:prstGeom xmlns:a="http://schemas.openxmlformats.org/drawingml/2006/main" prst="rect">
+            <a:avLst/>
+          </a:prstGeom>
+          <a:solidFill xmlns:a="http://schemas.openxmlformats.org/drawingml/2006/main">
+            <a:srgbClr val="D0EDFA"/>
+          </a:solidFill>
+          <a:ln xmlns:a="http://schemas.openxmlformats.org/drawingml/2006/main" w="0">
+            <a:solidFill>
+              <a:srgbClr val="D0EDFA"/>
+            </a:solidFill>
+            <a:prstDash val="solid"/>
+          </a:ln>
+        </p:spPr>
+      </p:sp>
+      <p:sp>
+        <p:nvSpPr>
+          <p:cNvPr id="15" name="">
+            <a:extLst xmlns:a="http://schemas.openxmlformats.org/drawingml/2006/main">
+              <a:ext uri="{FF2B5EF4-FFF2-40B4-BE49-F238E27FC236}">
+                <a16:creationId xmlns:a16="http://schemas.microsoft.com/office/drawing/2014/main" id="{4999156A-634A-4015-9001-DD0D76609E1E}"/>
+              </a:ext>
+            </a:extLst>
+          </p:cNvPr>
+          <p:cNvSpPr>
+            <a:spLocks xmlns:a="http://schemas.openxmlformats.org/drawingml/2006/main" noGrp="1"/>
+          </p:cNvSpPr>
+          <p:nvPr/>
+        </p:nvSpPr>
+        <p:spPr>
+          <a:xfrm xmlns:a="http://schemas.openxmlformats.org/drawingml/2006/main">
+            <a:off x="6438900" y="2038350"/>
+            <a:ext cx="3429000" cy="228600"/>
+          </a:xfrm>
+          <a:prstGeom xmlns:a="http://schemas.openxmlformats.org/drawingml/2006/main" prst="rect">
+            <a:avLst/>
+          </a:prstGeom>
+          <a:noFill xmlns:a="http://schemas.openxmlformats.org/drawingml/2006/main"/>
+          <a:ln xmlns:a="http://schemas.openxmlformats.org/drawingml/2006/main" w="0">
+            <a:noFill/>
+            <a:prstDash val="solid"/>
+          </a:ln>
+        </p:spPr>
+        <p:txBody>
+          <a:bodyPr xmlns:a="http://schemas.openxmlformats.org/drawingml/2006/main" anchor="t"/>
+          <a:lstStyle xmlns:a="http://schemas.openxmlformats.org/drawingml/2006/main"/>
+          <a:p xmlns:a="http://schemas.openxmlformats.org/drawingml/2006/main">
+            <a:pPr algn="l">
+              <a:buNone/>
+              <a:defRPr sz="1200" b="1">
+                <a:solidFill>
+                  <a:srgbClr val="3D8DFF"/>
+                </a:solidFill>
+              </a:defRPr>
+            </a:pPr>
+            <a:r>
+              <a:rPr sz="1200" b="1">
+                <a:solidFill>
+                  <a:srgbClr val="3D8DFF"/>
+                </a:solidFill>
+              </a:rPr>
+              <a:t>THE VERDICT</a:t>
+            </a:r>
+          </a:p>
+        </p:txBody>
+      </p:sp>
+      <p:sp>
+        <p:nvSpPr>
+          <p:cNvPr id="16" name="">
+            <a:extLst xmlns:a="http://schemas.openxmlformats.org/drawingml/2006/main">
+              <a:ext uri="{FF2B5EF4-FFF2-40B4-BE49-F238E27FC236}">
+                <a16:creationId xmlns:a16="http://schemas.microsoft.com/office/drawing/2014/main" id="{3ACBAC50-34EF-4B5F-8046-86B97339EB4B}"/>
+              </a:ext>
+            </a:extLst>
+          </p:cNvPr>
+          <p:cNvSpPr>
+            <a:spLocks xmlns:a="http://schemas.openxmlformats.org/drawingml/2006/main" noGrp="1"/>
+          </p:cNvSpPr>
+          <p:nvPr/>
+        </p:nvSpPr>
+        <p:spPr>
+          <a:xfrm xmlns:a="http://schemas.openxmlformats.org/drawingml/2006/main">
+            <a:off x="6438900" y="2457450"/>
+            <a:ext cx="4762500" cy="704850"/>
+          </a:xfrm>
+          <a:prstGeom xmlns:a="http://schemas.openxmlformats.org/drawingml/2006/main" prst="rect">
+            <a:avLst/>
+          </a:prstGeom>
+          <a:noFill xmlns:a="http://schemas.openxmlformats.org/drawingml/2006/main"/>
+          <a:ln xmlns:a="http://schemas.openxmlformats.org/drawingml/2006/main" w="0">
+            <a:noFill/>
+            <a:prstDash val="solid"/>
+          </a:ln>
+        </p:spPr>
+        <p:txBody>
+          <a:bodyPr xmlns:a="http://schemas.openxmlformats.org/drawingml/2006/main" anchor="t"/>
+          <a:lstStyle xmlns:a="http://schemas.openxmlformats.org/drawingml/2006/main"/>
+          <a:p xmlns:a="http://schemas.openxmlformats.org/drawingml/2006/main">
+            <a:pPr algn="l">
+              <a:buNone/>
+              <a:defRPr sz="2325" b="1">
+                <a:solidFill>
+                  <a:srgbClr val="000000"/>
+                </a:solidFill>
+              </a:defRPr>
+            </a:pPr>
+            <a:r>
+              <a:rPr sz="2325" b="1">
+                <a:solidFill>
+                  <a:srgbClr val="000000"/>
+                </a:solidFill>
+              </a:rPr>
+              <a:t>The attention-stock explanation failed its follow-up.</a:t>
+            </a:r>
+          </a:p>
+        </p:txBody>
+      </p:sp>
+      <p:sp>
+        <p:nvSpPr>
+          <p:cNvPr id="17" name="">
+            <a:extLst xmlns:a="http://schemas.openxmlformats.org/drawingml/2006/main">
+              <a:ext uri="{FF2B5EF4-FFF2-40B4-BE49-F238E27FC236}">
+                <a16:creationId xmlns:a16="http://schemas.microsoft.com/office/drawing/2014/main" id="{6FEF46A9-776C-4C9D-83FA-47DE4A13552D}"/>
+              </a:ext>
+            </a:extLst>
+          </p:cNvPr>
+          <p:cNvSpPr>
+            <a:spLocks xmlns:a="http://schemas.openxmlformats.org/drawingml/2006/main" noGrp="1"/>
+          </p:cNvSpPr>
+          <p:nvPr/>
+        </p:nvSpPr>
+        <p:spPr>
+          <a:xfrm xmlns:a="http://schemas.openxmlformats.org/drawingml/2006/main">
+            <a:off x="6457950" y="3562350"/>
+            <a:ext cx="85725" cy="85725"/>
+          </a:xfrm>
+          <a:prstGeom xmlns:a="http://schemas.openxmlformats.org/drawingml/2006/main" prst="rect">
+            <a:avLst/>
+          </a:prstGeom>
+          <a:solidFill xmlns:a="http://schemas.openxmlformats.org/drawingml/2006/main">
+            <a:srgbClr val="3D8DFF"/>
+          </a:solidFill>
+          <a:ln xmlns:a="http://schemas.openxmlformats.org/drawingml/2006/main" w="0">
+            <a:solidFill>
+              <a:srgbClr val="3D8DFF"/>
+            </a:solidFill>
+            <a:prstDash val="solid"/>
+          </a:ln>
+        </p:spPr>
+      </p:sp>
+      <p:sp>
+        <p:nvSpPr>
+          <p:cNvPr id="18" name="">
+            <a:extLst xmlns:a="http://schemas.openxmlformats.org/drawingml/2006/main">
+              <a:ext uri="{FF2B5EF4-FFF2-40B4-BE49-F238E27FC236}">
+                <a16:creationId xmlns:a16="http://schemas.microsoft.com/office/drawing/2014/main" id="{3C12383C-DAE5-4142-8A8C-4E9718DF81C1}"/>
+              </a:ext>
+            </a:extLst>
+          </p:cNvPr>
+          <p:cNvSpPr>
+            <a:spLocks xmlns:a="http://schemas.openxmlformats.org/drawingml/2006/main" noGrp="1"/>
+          </p:cNvSpPr>
+          <p:nvPr/>
+        </p:nvSpPr>
+        <p:spPr>
+          <a:xfrm xmlns:a="http://schemas.openxmlformats.org/drawingml/2006/main">
+            <a:off x="6667500" y="3486150"/>
+            <a:ext cx="4552950" cy="457200"/>
+          </a:xfrm>
+          <a:prstGeom xmlns:a="http://schemas.openxmlformats.org/drawingml/2006/main" prst="rect">
+            <a:avLst/>
+          </a:prstGeom>
+          <a:noFill xmlns:a="http://schemas.openxmlformats.org/drawingml/2006/main"/>
+          <a:ln xmlns:a="http://schemas.openxmlformats.org/drawingml/2006/main" w="0">
+            <a:noFill/>
+            <a:prstDash val="solid"/>
+          </a:ln>
+        </p:spPr>
+        <p:txBody>
+          <a:bodyPr xmlns:a="http://schemas.openxmlformats.org/drawingml/2006/main" anchor="t"/>
+          <a:lstStyle xmlns:a="http://schemas.openxmlformats.org/drawingml/2006/main"/>
+          <a:p xmlns:a="http://schemas.openxmlformats.org/drawingml/2006/main">
+            <a:pPr algn="l">
+              <a:buNone/>
+              <a:defRPr sz="1500" b="0">
+                <a:solidFill>
+                  <a:srgbClr val="24364B"/>
+                </a:solidFill>
+              </a:defRPr>
+            </a:pPr>
+            <a:r>
+              <a:rPr sz="1500" b="0">
+                <a:solidFill>
+                  <a:srgbClr val="24364B"/>
+                </a:solidFill>
+              </a:rPr>
+              <a:t>Matched difference: −3.34 pp; one-sided p = .818.</a:t>
+            </a:r>
+          </a:p>
+        </p:txBody>
+      </p:sp>
+      <p:sp>
+        <p:nvSpPr>
+          <p:cNvPr id="19" name="">
+            <a:extLst xmlns:a="http://schemas.openxmlformats.org/drawingml/2006/main">
+              <a:ext uri="{FF2B5EF4-FFF2-40B4-BE49-F238E27FC236}">
+                <a16:creationId xmlns:a16="http://schemas.microsoft.com/office/drawing/2014/main" id="{19F3040F-A033-4C52-A58E-C9DCB58D7D70}"/>
+              </a:ext>
+            </a:extLst>
+          </p:cNvPr>
+          <p:cNvSpPr>
+            <a:spLocks xmlns:a="http://schemas.openxmlformats.org/drawingml/2006/main" noGrp="1"/>
+          </p:cNvSpPr>
+          <p:nvPr/>
+        </p:nvSpPr>
+        <p:spPr>
+          <a:xfrm xmlns:a="http://schemas.openxmlformats.org/drawingml/2006/main">
+            <a:off x="6457950" y="4133850"/>
+            <a:ext cx="85725" cy="85725"/>
+          </a:xfrm>
+          <a:prstGeom xmlns:a="http://schemas.openxmlformats.org/drawingml/2006/main" prst="rect">
+            <a:avLst/>
+          </a:prstGeom>
+          <a:solidFill xmlns:a="http://schemas.openxmlformats.org/drawingml/2006/main">
+            <a:srgbClr val="3D8DFF"/>
+          </a:solidFill>
+          <a:ln xmlns:a="http://schemas.openxmlformats.org/drawingml/2006/main" w="0">
+            <a:solidFill>
+              <a:srgbClr val="3D8DFF"/>
+            </a:solidFill>
+            <a:prstDash val="solid"/>
+          </a:ln>
+        </p:spPr>
+      </p:sp>
+      <p:sp>
+        <p:nvSpPr>
+          <p:cNvPr id="20" name="">
+            <a:extLst xmlns:a="http://schemas.openxmlformats.org/drawingml/2006/main">
+              <a:ext uri="{FF2B5EF4-FFF2-40B4-BE49-F238E27FC236}">
+                <a16:creationId xmlns:a16="http://schemas.microsoft.com/office/drawing/2014/main" id="{AD7171E4-EE1B-4DE4-885F-51E08EDA52A3}"/>
+              </a:ext>
+            </a:extLst>
+          </p:cNvPr>
+          <p:cNvSpPr>
+            <a:spLocks xmlns:a="http://schemas.openxmlformats.org/drawingml/2006/main" noGrp="1"/>
+          </p:cNvSpPr>
+          <p:nvPr/>
+        </p:nvSpPr>
+        <p:spPr>
+          <a:xfrm xmlns:a="http://schemas.openxmlformats.org/drawingml/2006/main">
+            <a:off x="6667500" y="4057650"/>
+            <a:ext cx="4552950" cy="457200"/>
+          </a:xfrm>
+          <a:prstGeom xmlns:a="http://schemas.openxmlformats.org/drawingml/2006/main" prst="rect">
+            <a:avLst/>
+          </a:prstGeom>
+          <a:noFill xmlns:a="http://schemas.openxmlformats.org/drawingml/2006/main"/>
+          <a:ln xmlns:a="http://schemas.openxmlformats.org/drawingml/2006/main" w="0">
+            <a:noFill/>
+            <a:prstDash val="solid"/>
+          </a:ln>
+        </p:spPr>
+        <p:txBody>
+          <a:bodyPr xmlns:a="http://schemas.openxmlformats.org/drawingml/2006/main" anchor="t"/>
+          <a:lstStyle xmlns:a="http://schemas.openxmlformats.org/drawingml/2006/main"/>
+          <a:p xmlns:a="http://schemas.openxmlformats.org/drawingml/2006/main">
+            <a:pPr algn="l">
+              <a:buNone/>
+              <a:defRPr sz="1500" b="0">
+                <a:solidFill>
+                  <a:srgbClr val="24364B"/>
+                </a:solidFill>
+              </a:defRPr>
+            </a:pPr>
+            <a:r>
+              <a:rPr sz="1500" b="0">
+                <a:solidFill>
+                  <a:srgbClr val="24364B"/>
+                </a:solidFill>
+              </a:rPr>
+              <a:t>Balance also failed: the cohorts came from different environments.</a:t>
+            </a:r>
+          </a:p>
+        </p:txBody>
+      </p:sp>
+      <p:sp>
+        <p:nvSpPr>
+          <p:cNvPr id="21" name="">
+            <a:extLst xmlns:a="http://schemas.openxmlformats.org/drawingml/2006/main">
+              <a:ext uri="{FF2B5EF4-FFF2-40B4-BE49-F238E27FC236}">
+                <a16:creationId xmlns:a16="http://schemas.microsoft.com/office/drawing/2014/main" id="{7CC0D4FA-0504-4ABB-AFC5-597134753807}"/>
+              </a:ext>
+            </a:extLst>
+          </p:cNvPr>
+          <p:cNvSpPr>
+            <a:spLocks xmlns:a="http://schemas.openxmlformats.org/drawingml/2006/main" noGrp="1"/>
+          </p:cNvSpPr>
+          <p:nvPr/>
+        </p:nvSpPr>
+        <p:spPr>
+          <a:xfrm xmlns:a="http://schemas.openxmlformats.org/drawingml/2006/main">
+            <a:off x="495300" y="5219700"/>
+            <a:ext cx="11201400" cy="1028700"/>
+          </a:xfrm>
+          <a:prstGeom xmlns:a="http://schemas.openxmlformats.org/drawingml/2006/main" prst="rect">
+            <a:avLst/>
+          </a:prstGeom>
+          <a:solidFill xmlns:a="http://schemas.openxmlformats.org/drawingml/2006/main">
+            <a:srgbClr val="24364B"/>
+          </a:solidFill>
+          <a:ln xmlns:a="http://schemas.openxmlformats.org/drawingml/2006/main" w="0">
+            <a:solidFill>
+              <a:srgbClr val="24364B"/>
+            </a:solidFill>
+            <a:prstDash val="solid"/>
+          </a:ln>
+        </p:spPr>
+      </p:sp>
+      <p:sp>
+        <p:nvSpPr>
+          <p:cNvPr id="22" name="">
+            <a:extLst xmlns:a="http://schemas.openxmlformats.org/drawingml/2006/main">
+              <a:ext uri="{FF2B5EF4-FFF2-40B4-BE49-F238E27FC236}">
+                <a16:creationId xmlns:a16="http://schemas.microsoft.com/office/drawing/2014/main" id="{5D24E5B7-6C49-4DEE-B468-9C2F50EB95C2}"/>
+              </a:ext>
+            </a:extLst>
+          </p:cNvPr>
+          <p:cNvSpPr>
+            <a:spLocks xmlns:a="http://schemas.openxmlformats.org/drawingml/2006/main" noGrp="1"/>
+          </p:cNvSpPr>
+          <p:nvPr/>
+        </p:nvSpPr>
+        <p:spPr>
+          <a:xfrm xmlns:a="http://schemas.openxmlformats.org/drawingml/2006/main">
+            <a:off x="762000" y="5448300"/>
+            <a:ext cx="2571750" cy="228600"/>
+          </a:xfrm>
+          <a:prstGeom xmlns:a="http://schemas.openxmlformats.org/drawingml/2006/main" prst="rect">
+            <a:avLst/>
+          </a:prstGeom>
+          <a:noFill xmlns:a="http://schemas.openxmlformats.org/drawingml/2006/main"/>
+          <a:ln xmlns:a="http://schemas.openxmlformats.org/drawingml/2006/main" w="0">
+            <a:noFill/>
+            <a:prstDash val="solid"/>
+          </a:ln>
+        </p:spPr>
+        <p:txBody>
+          <a:bodyPr xmlns:a="http://schemas.openxmlformats.org/drawingml/2006/main" anchor="t"/>
+          <a:lstStyle xmlns:a="http://schemas.openxmlformats.org/drawingml/2006/main"/>
+          <a:p xmlns:a="http://schemas.openxmlformats.org/drawingml/2006/main">
+            <a:pPr algn="l">
+              <a:buNone/>
+              <a:defRPr sz="1125" b="1">
+                <a:solidFill>
+                  <a:srgbClr val="D0EDFA"/>
+                </a:solidFill>
+              </a:defRPr>
+            </a:pPr>
+            <a:r>
+              <a:rPr sz="1125" b="1">
+                <a:solidFill>
+                  <a:srgbClr val="D0EDFA"/>
+                </a:solidFill>
+              </a:rPr>
+              <a:t>CURRENT STOP</a:t>
+            </a:r>
+          </a:p>
+        </p:txBody>
+      </p:sp>
+      <p:sp>
+        <p:nvSpPr>
+          <p:cNvPr id="23" name="">
+            <a:extLst xmlns:a="http://schemas.openxmlformats.org/drawingml/2006/main">
+              <a:ext uri="{FF2B5EF4-FFF2-40B4-BE49-F238E27FC236}">
+                <a16:creationId xmlns:a16="http://schemas.microsoft.com/office/drawing/2014/main" id="{29B518C2-2C4A-48C8-907D-050088481304}"/>
+              </a:ext>
+            </a:extLst>
+          </p:cNvPr>
+          <p:cNvSpPr>
+            <a:spLocks xmlns:a="http://schemas.openxmlformats.org/drawingml/2006/main" noGrp="1"/>
+          </p:cNvSpPr>
+          <p:nvPr/>
+        </p:nvSpPr>
+        <p:spPr>
+          <a:xfrm xmlns:a="http://schemas.openxmlformats.org/drawingml/2006/main">
+            <a:off x="3429000" y="5391150"/>
+            <a:ext cx="7905750" cy="628650"/>
+          </a:xfrm>
+          <a:prstGeom xmlns:a="http://schemas.openxmlformats.org/drawingml/2006/main" prst="rect">
+            <a:avLst/>
+          </a:prstGeom>
+          <a:noFill xmlns:a="http://schemas.openxmlformats.org/drawingml/2006/main"/>
+          <a:ln xmlns:a="http://schemas.openxmlformats.org/drawingml/2006/main" w="0">
+            <a:noFill/>
+            <a:prstDash val="solid"/>
+          </a:ln>
+        </p:spPr>
+        <p:txBody>
+          <a:bodyPr xmlns:a="http://schemas.openxmlformats.org/drawingml/2006/main" anchor="t"/>
+          <a:lstStyle xmlns:a="http://schemas.openxmlformats.org/drawingml/2006/main"/>
+          <a:p xmlns:a="http://schemas.openxmlformats.org/drawingml/2006/main">
+            <a:pPr algn="l">
+              <a:buNone/>
+              <a:defRPr sz="1575" b="1">
+                <a:solidFill>
+                  <a:srgbClr val="FFFFFF"/>
+                </a:solidFill>
+              </a:defRPr>
+            </a:pPr>
+            <a:r>
+              <a:rPr sz="1575" b="1">
+                <a:solidFill>
+                  <a:srgbClr val="FFFFFF"/>
+                </a:solidFill>
+              </a:rPr>
+              <a:t>Do not trade the label. Carry forward the question: which measurable, pre-outcome features separate rebound environments from non-rebound environments?</a:t>
             </a:r>
           </a:p>
         </p:txBody>

</xml_diff>